<commit_message>
finished up presentation slides
</commit_message>
<xml_diff>
--- a/Presentation/DS3001.pptx
+++ b/Presentation/DS3001.pptx
@@ -130,9 +130,6 @@
         </p15:guide>
       </p15:sldGuideLst>
     </p:ext>
-    <p:ext uri="{2D200454-40CA-4A62-9FC3-DE9A4176ACB9}">
-      <p15:notesGuideLst xmlns:p15="http://schemas.microsoft.com/office/powerpoint/2012/main"/>
-    </p:ext>
   </p:extLst>
 </p:presentation>
 </file>
@@ -149,8 +146,9 @@
 <file path=ppt/revisionInfo.xml><?xml version="1.0" encoding="utf-8"?>
 <p1510:revInfo xmlns:a="http://schemas.openxmlformats.org/drawingml/2006/main" xmlns:r="http://schemas.openxmlformats.org/officeDocument/2006/relationships" xmlns:p1510="http://schemas.microsoft.com/office/powerpoint/2015/10/main">
   <p1510:revLst>
-    <p1510:client id="{2A68DAAB-8078-1FF4-907D-52DBA4180B05}" v="894" dt="2026-05-03T18:00:23.688"/>
+    <p1510:client id="{2A68DAAB-8078-1FF4-907D-52DBA4180B05}" v="958" dt="2026-05-03T18:14:24.174"/>
     <p1510:client id="{622231D8-95B1-3A76-5621-BE51AFAC02E6}" v="1" dt="2026-05-03T16:45:38.515"/>
+    <p1510:client id="{705DC7BC-3DCC-2A9F-4804-3044495A960F}" v="1454" dt="2026-05-04T03:13:01.587"/>
     <p1510:client id="{E83F5141-F3DE-C40C-B917-B03E6B8086C6}" v="65" dt="2026-05-03T17:02:06.549"/>
   </p1510:revLst>
 </p1510:revInfo>
@@ -761,7 +759,7 @@
           <a:p>
             <a:pPr lvl="0"/>
             <a:r>
-              <a:rPr lang="en-US" dirty="0"/>
+              <a:rPr lang="en-US"/>
               <a:t>Click to edit Master title style</a:t>
             </a:r>
           </a:p>
@@ -814,7 +812,6 @@
               <a:rPr lang="en-US"/>
               <a:t>Click to edit Master subtitle style</a:t>
             </a:r>
-            <a:endParaRPr lang="en-US" dirty="0"/>
           </a:p>
         </p:txBody>
       </p:sp>
@@ -859,7 +856,6 @@
               <a:rPr lang="en-US"/>
               <a:t>Presentation title</a:t>
             </a:r>
-            <a:endParaRPr lang="en-US" dirty="0"/>
           </a:p>
         </p:txBody>
       </p:sp>
@@ -1204,7 +1200,7 @@
           </a:lstStyle>
           <a:p>
             <a:r>
-              <a:rPr lang="en-US" dirty="0"/>
+              <a:rPr lang="en-US"/>
               <a:t>Click to edit Master title style</a:t>
             </a:r>
           </a:p>
@@ -1254,7 +1250,7 @@
           <a:p>
             <a:pPr lvl="0"/>
             <a:r>
-              <a:rPr lang="en-US" dirty="0"/>
+              <a:rPr lang="en-US"/>
               <a:t>Click to edit Master subtitle style</a:t>
             </a:r>
           </a:p>
@@ -1301,7 +1297,6 @@
               <a:rPr lang="en-US"/>
               <a:t>Presentation title</a:t>
             </a:r>
-            <a:endParaRPr lang="en-US" dirty="0"/>
           </a:p>
         </p:txBody>
       </p:sp>
@@ -1346,7 +1341,7 @@
               <a:rPr lang="en-US" smtClean="0"/>
               <a:t>5/3/2026</a:t>
             </a:fld>
-            <a:endParaRPr lang="en-US" dirty="0"/>
+            <a:endParaRPr lang="en-US"/>
           </a:p>
         </p:txBody>
       </p:sp>
@@ -1392,7 +1387,7 @@
               <a:pPr/>
               <a:t>‹#›</a:t>
             </a:fld>
-            <a:endParaRPr lang="en-US" dirty="0"/>
+            <a:endParaRPr lang="en-US"/>
           </a:p>
         </p:txBody>
       </p:sp>
@@ -1516,7 +1511,7 @@
           </a:lstStyle>
           <a:p>
             <a:r>
-              <a:rPr lang="en-US" dirty="0"/>
+              <a:rPr lang="en-US"/>
               <a:t> </a:t>
             </a:r>
           </a:p>
@@ -1713,7 +1708,7 @@
           </a:lstStyle>
           <a:p>
             <a:r>
-              <a:rPr lang="en-US" dirty="0"/>
+              <a:rPr lang="en-US"/>
               <a:t>Click to edit Master title style</a:t>
             </a:r>
           </a:p>
@@ -1797,7 +1792,6 @@
               <a:rPr lang="en-US"/>
               <a:t>Click to edit Master subtitle style</a:t>
             </a:r>
-            <a:endParaRPr lang="en-US" dirty="0"/>
           </a:p>
         </p:txBody>
       </p:sp>
@@ -1842,7 +1836,7 @@
           </a:lstStyle>
           <a:p>
             <a:r>
-              <a:rPr lang="en-US" dirty="0"/>
+              <a:rPr lang="en-US"/>
               <a:t> </a:t>
             </a:r>
           </a:p>
@@ -1889,7 +1883,6 @@
               <a:rPr lang="en-US"/>
               <a:t>Presentation title</a:t>
             </a:r>
-            <a:endParaRPr lang="en-US" dirty="0"/>
           </a:p>
         </p:txBody>
       </p:sp>
@@ -1934,7 +1927,7 @@
               <a:rPr lang="en-US" smtClean="0"/>
               <a:t>5/3/2026</a:t>
             </a:fld>
-            <a:endParaRPr lang="en-US" dirty="0"/>
+            <a:endParaRPr lang="en-US"/>
           </a:p>
         </p:txBody>
       </p:sp>
@@ -1980,7 +1973,7 @@
               <a:pPr/>
               <a:t>‹#›</a:t>
             </a:fld>
-            <a:endParaRPr lang="en-US" dirty="0"/>
+            <a:endParaRPr lang="en-US"/>
           </a:p>
         </p:txBody>
       </p:sp>
@@ -2279,7 +2272,7 @@
           <a:p>
             <a:pPr lvl="0"/>
             <a:r>
-              <a:rPr lang="en-US" dirty="0"/>
+              <a:rPr lang="en-US"/>
               <a:t>SECTION HEADER</a:t>
             </a:r>
           </a:p>
@@ -2326,7 +2319,6 @@
               <a:rPr lang="en-US"/>
               <a:t>Presentation title</a:t>
             </a:r>
-            <a:endParaRPr lang="en-US" dirty="0"/>
           </a:p>
         </p:txBody>
       </p:sp>
@@ -2371,7 +2363,7 @@
               <a:rPr lang="en-US" smtClean="0"/>
               <a:t>5/3/2026</a:t>
             </a:fld>
-            <a:endParaRPr lang="en-US" dirty="0"/>
+            <a:endParaRPr lang="en-US"/>
           </a:p>
         </p:txBody>
       </p:sp>
@@ -2417,7 +2409,7 @@
               <a:pPr/>
               <a:t>‹#›</a:t>
             </a:fld>
-            <a:endParaRPr lang="en-US" dirty="0"/>
+            <a:endParaRPr lang="en-US"/>
           </a:p>
         </p:txBody>
       </p:sp>
@@ -2670,7 +2662,7 @@
           </a:lstStyle>
           <a:p>
             <a:r>
-              <a:rPr lang="en-US" dirty="0"/>
+              <a:rPr lang="en-US"/>
               <a:t>AGENDA</a:t>
             </a:r>
           </a:p>
@@ -2796,7 +2788,6 @@
               <a:rPr lang="en-US"/>
               <a:t>Fifth level</a:t>
             </a:r>
-            <a:endParaRPr lang="en-US" dirty="0"/>
           </a:p>
         </p:txBody>
       </p:sp>
@@ -2841,7 +2832,6 @@
               <a:rPr lang="en-US"/>
               <a:t>Presentation title</a:t>
             </a:r>
-            <a:endParaRPr lang="en-US" dirty="0"/>
           </a:p>
         </p:txBody>
       </p:sp>
@@ -2886,7 +2876,7 @@
               <a:rPr lang="en-US" smtClean="0"/>
               <a:t>5/3/2026</a:t>
             </a:fld>
-            <a:endParaRPr lang="en-US" dirty="0"/>
+            <a:endParaRPr lang="en-US"/>
           </a:p>
         </p:txBody>
       </p:sp>
@@ -2932,7 +2922,7 @@
               <a:pPr/>
               <a:t>‹#›</a:t>
             </a:fld>
-            <a:endParaRPr lang="en-US" dirty="0"/>
+            <a:endParaRPr lang="en-US"/>
           </a:p>
         </p:txBody>
       </p:sp>
@@ -3065,7 +3055,7 @@
           </a:lstStyle>
           <a:p>
             <a:r>
-              <a:rPr lang="en-US" dirty="0"/>
+              <a:rPr lang="en-US"/>
               <a:t>AGENDA</a:t>
             </a:r>
           </a:p>
@@ -3206,7 +3196,6 @@
               <a:rPr lang="en-US"/>
               <a:t>Fifth level</a:t>
             </a:r>
-            <a:endParaRPr lang="en-US" dirty="0"/>
           </a:p>
         </p:txBody>
       </p:sp>
@@ -3251,7 +3240,6 @@
               <a:rPr lang="en-US"/>
               <a:t>Presentation title</a:t>
             </a:r>
-            <a:endParaRPr lang="en-US" dirty="0"/>
           </a:p>
         </p:txBody>
       </p:sp>
@@ -3296,7 +3284,7 @@
               <a:rPr lang="en-US" smtClean="0"/>
               <a:t>5/3/2026</a:t>
             </a:fld>
-            <a:endParaRPr lang="en-US" dirty="0"/>
+            <a:endParaRPr lang="en-US"/>
           </a:p>
         </p:txBody>
       </p:sp>
@@ -3342,7 +3330,7 @@
               <a:pPr/>
               <a:t>‹#›</a:t>
             </a:fld>
-            <a:endParaRPr lang="en-US" dirty="0"/>
+            <a:endParaRPr lang="en-US"/>
           </a:p>
         </p:txBody>
       </p:sp>
@@ -3524,7 +3512,7 @@
           </a:lstStyle>
           <a:p>
             <a:r>
-              <a:rPr lang="en-US" dirty="0"/>
+              <a:rPr lang="en-US"/>
               <a:t>AGENDA</a:t>
             </a:r>
           </a:p>
@@ -3570,7 +3558,7 @@
           </a:lstStyle>
           <a:p>
             <a:r>
-              <a:rPr lang="en-US" dirty="0"/>
+              <a:rPr lang="en-US"/>
               <a:t> </a:t>
             </a:r>
           </a:p>
@@ -3696,7 +3684,6 @@
               <a:rPr lang="en-US"/>
               <a:t>Fifth level</a:t>
             </a:r>
-            <a:endParaRPr lang="en-US" dirty="0"/>
           </a:p>
         </p:txBody>
       </p:sp>
@@ -3733,7 +3720,6 @@
               <a:rPr lang="en-US"/>
               <a:t>Presentation title</a:t>
             </a:r>
-            <a:endParaRPr lang="en-US" dirty="0"/>
           </a:p>
         </p:txBody>
       </p:sp>
@@ -3770,7 +3756,7 @@
               <a:rPr lang="en-US" smtClean="0"/>
               <a:t>5/3/2026</a:t>
             </a:fld>
-            <a:endParaRPr lang="en-US" dirty="0"/>
+            <a:endParaRPr lang="en-US"/>
           </a:p>
         </p:txBody>
       </p:sp>
@@ -3807,7 +3793,7 @@
               <a:rPr lang="en-US" smtClean="0"/>
               <a:t>‹#›</a:t>
             </a:fld>
-            <a:endParaRPr lang="en-US" dirty="0"/>
+            <a:endParaRPr lang="en-US"/>
           </a:p>
         </p:txBody>
       </p:sp>
@@ -3935,7 +3921,7 @@
           </a:lstStyle>
           <a:p>
             <a:r>
-              <a:rPr lang="en-US" dirty="0"/>
+              <a:rPr lang="en-US"/>
               <a:t>Click to edit Master title style</a:t>
             </a:r>
           </a:p>
@@ -4186,7 +4172,6 @@
               <a:rPr lang="en-US"/>
               <a:t>Presentation title</a:t>
             </a:r>
-            <a:endParaRPr lang="en-US" dirty="0"/>
           </a:p>
         </p:txBody>
       </p:sp>
@@ -4455,7 +4440,7 @@
           </a:lstStyle>
           <a:p>
             <a:r>
-              <a:rPr lang="en-US" dirty="0"/>
+              <a:rPr lang="en-US"/>
               <a:t>Click to edit Master title style</a:t>
             </a:r>
           </a:p>
@@ -4523,7 +4508,6 @@
               <a:rPr lang="en-US"/>
               <a:t>Fifth level</a:t>
             </a:r>
-            <a:endParaRPr lang="en-US" dirty="0"/>
           </a:p>
         </p:txBody>
       </p:sp>
@@ -4560,7 +4544,6 @@
               <a:rPr lang="en-US"/>
               <a:t>Presentation title</a:t>
             </a:r>
-            <a:endParaRPr lang="en-US" dirty="0"/>
           </a:p>
         </p:txBody>
       </p:sp>
@@ -4597,7 +4580,7 @@
               <a:rPr lang="en-US" smtClean="0"/>
               <a:t>5/3/2026</a:t>
             </a:fld>
-            <a:endParaRPr lang="en-US" dirty="0"/>
+            <a:endParaRPr lang="en-US"/>
           </a:p>
         </p:txBody>
       </p:sp>
@@ -4634,7 +4617,7 @@
               <a:rPr lang="en-US" smtClean="0"/>
               <a:t>‹#›</a:t>
             </a:fld>
-            <a:endParaRPr lang="en-US" dirty="0"/>
+            <a:endParaRPr lang="en-US"/>
           </a:p>
         </p:txBody>
       </p:sp>
@@ -4819,7 +4802,7 @@
           </a:lstStyle>
           <a:p>
             <a:r>
-              <a:rPr lang="en-US" dirty="0"/>
+              <a:rPr lang="en-US"/>
               <a:t>Click to edit Master title style</a:t>
             </a:r>
           </a:p>
@@ -4887,7 +4870,6 @@
               <a:rPr lang="en-US"/>
               <a:t>Fifth level</a:t>
             </a:r>
-            <a:endParaRPr lang="en-US" dirty="0"/>
           </a:p>
         </p:txBody>
       </p:sp>
@@ -4960,7 +4942,7 @@
               <a:rPr lang="en-US" smtClean="0"/>
               <a:t>5/3/2026</a:t>
             </a:fld>
-            <a:endParaRPr lang="en-US" dirty="0"/>
+            <a:endParaRPr lang="en-US"/>
           </a:p>
         </p:txBody>
       </p:sp>
@@ -4997,7 +4979,7 @@
               <a:rPr lang="en-US" smtClean="0"/>
               <a:t>‹#›</a:t>
             </a:fld>
-            <a:endParaRPr lang="en-US" dirty="0"/>
+            <a:endParaRPr lang="en-US"/>
           </a:p>
         </p:txBody>
       </p:sp>
@@ -5182,7 +5164,7 @@
           </a:lstStyle>
           <a:p>
             <a:r>
-              <a:rPr lang="en-US" dirty="0"/>
+              <a:rPr lang="en-US"/>
               <a:t>Click to edit Master title style</a:t>
             </a:r>
           </a:p>
@@ -5250,7 +5232,6 @@
               <a:rPr lang="en-US"/>
               <a:t>Fifth level</a:t>
             </a:r>
-            <a:endParaRPr lang="en-US" dirty="0"/>
           </a:p>
         </p:txBody>
       </p:sp>
@@ -5287,7 +5268,6 @@
               <a:rPr lang="en-US"/>
               <a:t>Presentation title</a:t>
             </a:r>
-            <a:endParaRPr lang="en-US" dirty="0"/>
           </a:p>
         </p:txBody>
       </p:sp>
@@ -5324,7 +5304,7 @@
               <a:rPr lang="en-US" smtClean="0"/>
               <a:t>5/3/2026</a:t>
             </a:fld>
-            <a:endParaRPr lang="en-US" dirty="0"/>
+            <a:endParaRPr lang="en-US"/>
           </a:p>
         </p:txBody>
       </p:sp>
@@ -5361,7 +5341,7 @@
               <a:rPr lang="en-US" smtClean="0"/>
               <a:t>‹#›</a:t>
             </a:fld>
-            <a:endParaRPr lang="en-US" dirty="0"/>
+            <a:endParaRPr lang="en-US"/>
           </a:p>
         </p:txBody>
       </p:sp>
@@ -5546,7 +5526,7 @@
           </a:lstStyle>
           <a:p>
             <a:r>
-              <a:rPr lang="en-US" dirty="0"/>
+              <a:rPr lang="en-US"/>
               <a:t>Click to edit Master title style</a:t>
             </a:r>
           </a:p>
@@ -5614,7 +5594,6 @@
               <a:rPr lang="en-US"/>
               <a:t>Fifth level</a:t>
             </a:r>
-            <a:endParaRPr lang="en-US" dirty="0"/>
           </a:p>
         </p:txBody>
       </p:sp>
@@ -5695,7 +5674,6 @@
               <a:rPr lang="en-US"/>
               <a:t>Presentation title</a:t>
             </a:r>
-            <a:endParaRPr lang="en-US" dirty="0"/>
           </a:p>
         </p:txBody>
       </p:sp>
@@ -5725,7 +5703,7 @@
               <a:pPr/>
               <a:t>5/3/2026</a:t>
             </a:fld>
-            <a:endParaRPr lang="en-US" dirty="0"/>
+            <a:endParaRPr lang="en-US"/>
           </a:p>
         </p:txBody>
       </p:sp>
@@ -5755,7 +5733,7 @@
               <a:pPr/>
               <a:t>‹#›</a:t>
             </a:fld>
-            <a:endParaRPr lang="en-US" dirty="0"/>
+            <a:endParaRPr lang="en-US"/>
           </a:p>
         </p:txBody>
       </p:sp>
@@ -5838,7 +5816,7 @@
           </a:lstStyle>
           <a:p>
             <a:r>
-              <a:rPr lang="en-US" dirty="0"/>
+              <a:rPr lang="en-US"/>
               <a:t>Click to edit Master title style</a:t>
             </a:r>
           </a:p>
@@ -5906,7 +5884,6 @@
               <a:rPr lang="en-US"/>
               <a:t>Fifth level</a:t>
             </a:r>
-            <a:endParaRPr lang="en-US" dirty="0"/>
           </a:p>
         </p:txBody>
       </p:sp>
@@ -5943,7 +5920,6 @@
               <a:rPr lang="en-US"/>
               <a:t>Presentation title</a:t>
             </a:r>
-            <a:endParaRPr lang="en-US" dirty="0"/>
           </a:p>
         </p:txBody>
       </p:sp>
@@ -5980,7 +5956,7 @@
               <a:rPr lang="en-US" smtClean="0"/>
               <a:t>5/3/2026</a:t>
             </a:fld>
-            <a:endParaRPr lang="en-US" dirty="0"/>
+            <a:endParaRPr lang="en-US"/>
           </a:p>
         </p:txBody>
       </p:sp>
@@ -6017,7 +5993,7 @@
               <a:rPr lang="en-US" smtClean="0"/>
               <a:t>‹#›</a:t>
             </a:fld>
-            <a:endParaRPr lang="en-US" dirty="0"/>
+            <a:endParaRPr lang="en-US"/>
           </a:p>
         </p:txBody>
       </p:sp>
@@ -6200,7 +6176,7 @@
           </a:lstStyle>
           <a:p>
             <a:r>
-              <a:rPr lang="en-US" dirty="0"/>
+              <a:rPr lang="en-US"/>
               <a:t>Click to edit Master title style</a:t>
             </a:r>
           </a:p>
@@ -6328,7 +6304,7 @@
           </a:lstStyle>
           <a:p>
             <a:r>
-              <a:rPr lang="en-US" dirty="0"/>
+              <a:rPr lang="en-US"/>
               <a:t> </a:t>
             </a:r>
           </a:p>
@@ -6396,7 +6372,6 @@
               <a:rPr lang="en-US"/>
               <a:t>Fifth level</a:t>
             </a:r>
-            <a:endParaRPr lang="en-US" dirty="0"/>
           </a:p>
         </p:txBody>
       </p:sp>
@@ -6441,7 +6416,6 @@
               <a:rPr lang="en-US"/>
               <a:t>Presentation title</a:t>
             </a:r>
-            <a:endParaRPr lang="en-US" dirty="0"/>
           </a:p>
         </p:txBody>
       </p:sp>
@@ -6486,7 +6460,7 @@
               <a:rPr lang="en-US" smtClean="0"/>
               <a:t>5/3/2026</a:t>
             </a:fld>
-            <a:endParaRPr lang="en-US" dirty="0"/>
+            <a:endParaRPr lang="en-US"/>
           </a:p>
         </p:txBody>
       </p:sp>
@@ -6532,7 +6506,7 @@
               <a:pPr/>
               <a:t>‹#›</a:t>
             </a:fld>
-            <a:endParaRPr lang="en-US" dirty="0"/>
+            <a:endParaRPr lang="en-US"/>
           </a:p>
         </p:txBody>
       </p:sp>
@@ -6760,7 +6734,7 @@
           </a:lstStyle>
           <a:p>
             <a:r>
-              <a:rPr lang="en-US" dirty="0"/>
+              <a:rPr lang="en-US"/>
               <a:t>Click to edit Master title style</a:t>
             </a:r>
           </a:p>
@@ -6828,7 +6802,6 @@
               <a:rPr lang="en-US"/>
               <a:t>Fifth level</a:t>
             </a:r>
-            <a:endParaRPr lang="en-US" dirty="0"/>
           </a:p>
         </p:txBody>
       </p:sp>
@@ -6873,7 +6846,6 @@
               <a:rPr lang="en-US"/>
               <a:t>Presentation title</a:t>
             </a:r>
-            <a:endParaRPr lang="en-US" dirty="0"/>
           </a:p>
         </p:txBody>
       </p:sp>
@@ -6918,7 +6890,7 @@
               <a:rPr lang="en-US" smtClean="0"/>
               <a:t>5/3/2026</a:t>
             </a:fld>
-            <a:endParaRPr lang="en-US" dirty="0"/>
+            <a:endParaRPr lang="en-US"/>
           </a:p>
         </p:txBody>
       </p:sp>
@@ -6964,7 +6936,7 @@
               <a:pPr/>
               <a:t>‹#›</a:t>
             </a:fld>
-            <a:endParaRPr lang="en-US" dirty="0"/>
+            <a:endParaRPr lang="en-US"/>
           </a:p>
         </p:txBody>
       </p:sp>
@@ -7090,7 +7062,7 @@
           </a:lstStyle>
           <a:p>
             <a:r>
-              <a:rPr lang="en-US" dirty="0"/>
+              <a:rPr lang="en-US"/>
               <a:t> </a:t>
             </a:r>
           </a:p>
@@ -7320,7 +7292,7 @@
           </a:lstStyle>
           <a:p>
             <a:r>
-              <a:rPr lang="en-US" dirty="0"/>
+              <a:rPr lang="en-US"/>
               <a:t>Click to edit Master title style</a:t>
             </a:r>
           </a:p>
@@ -7448,7 +7420,7 @@
           </a:lstStyle>
           <a:p>
             <a:r>
-              <a:rPr lang="en-US" dirty="0"/>
+              <a:rPr lang="en-US"/>
               <a:t> </a:t>
             </a:r>
           </a:p>
@@ -7516,7 +7488,6 @@
               <a:rPr lang="en-US"/>
               <a:t>Fifth level</a:t>
             </a:r>
-            <a:endParaRPr lang="en-US" dirty="0"/>
           </a:p>
         </p:txBody>
       </p:sp>
@@ -7561,7 +7532,6 @@
               <a:rPr lang="en-US"/>
               <a:t>Presentation title</a:t>
             </a:r>
-            <a:endParaRPr lang="en-US" dirty="0"/>
           </a:p>
         </p:txBody>
       </p:sp>
@@ -7606,7 +7576,7 @@
               <a:rPr lang="en-US" smtClean="0"/>
               <a:t>5/3/2026</a:t>
             </a:fld>
-            <a:endParaRPr lang="en-US" dirty="0"/>
+            <a:endParaRPr lang="en-US"/>
           </a:p>
         </p:txBody>
       </p:sp>
@@ -7652,7 +7622,7 @@
               <a:pPr/>
               <a:t>‹#›</a:t>
             </a:fld>
-            <a:endParaRPr lang="en-US" dirty="0"/>
+            <a:endParaRPr lang="en-US"/>
           </a:p>
         </p:txBody>
       </p:sp>
@@ -7925,7 +7895,7 @@
           </a:lstStyle>
           <a:p>
             <a:r>
-              <a:rPr lang="en-US" dirty="0"/>
+              <a:rPr lang="en-US"/>
               <a:t>Click to edit Master title style</a:t>
             </a:r>
           </a:p>
@@ -7993,7 +7963,6 @@
               <a:rPr lang="en-US"/>
               <a:t>Fifth level</a:t>
             </a:r>
-            <a:endParaRPr lang="en-US" dirty="0"/>
           </a:p>
         </p:txBody>
       </p:sp>
@@ -8038,7 +8007,6 @@
               <a:rPr lang="en-US"/>
               <a:t>Presentation title</a:t>
             </a:r>
-            <a:endParaRPr lang="en-US" dirty="0"/>
           </a:p>
         </p:txBody>
       </p:sp>
@@ -8083,7 +8051,7 @@
               <a:rPr lang="en-US" smtClean="0"/>
               <a:t>5/3/2026</a:t>
             </a:fld>
-            <a:endParaRPr lang="en-US" dirty="0"/>
+            <a:endParaRPr lang="en-US"/>
           </a:p>
         </p:txBody>
       </p:sp>
@@ -8129,7 +8097,7 @@
               <a:pPr/>
               <a:t>‹#›</a:t>
             </a:fld>
-            <a:endParaRPr lang="en-US" dirty="0"/>
+            <a:endParaRPr lang="en-US"/>
           </a:p>
         </p:txBody>
       </p:sp>
@@ -8255,7 +8223,7 @@
           </a:lstStyle>
           <a:p>
             <a:r>
-              <a:rPr lang="en-US" dirty="0"/>
+              <a:rPr lang="en-US"/>
               <a:t> </a:t>
             </a:r>
           </a:p>
@@ -8532,7 +8500,7 @@
           </a:lstStyle>
           <a:p>
             <a:r>
-              <a:rPr lang="en-US" dirty="0"/>
+              <a:rPr lang="en-US"/>
               <a:t>Click to edit Master title style</a:t>
             </a:r>
           </a:p>
@@ -8582,7 +8550,7 @@
           </a:lstStyle>
           <a:p>
             <a:r>
-              <a:rPr lang="en-US" dirty="0"/>
+              <a:rPr lang="en-US"/>
               <a:t> </a:t>
             </a:r>
           </a:p>
@@ -8650,7 +8618,6 @@
               <a:rPr lang="en-US"/>
               <a:t>Fifth level</a:t>
             </a:r>
-            <a:endParaRPr lang="en-US" dirty="0"/>
           </a:p>
         </p:txBody>
       </p:sp>
@@ -8695,7 +8662,6 @@
               <a:rPr lang="en-US"/>
               <a:t>Presentation title</a:t>
             </a:r>
-            <a:endParaRPr lang="en-US" dirty="0"/>
           </a:p>
         </p:txBody>
       </p:sp>
@@ -8741,7 +8707,7 @@
               <a:rPr lang="en-US" smtClean="0"/>
               <a:t>5/3/2026</a:t>
             </a:fld>
-            <a:endParaRPr lang="en-US" dirty="0"/>
+            <a:endParaRPr lang="en-US"/>
           </a:p>
         </p:txBody>
       </p:sp>
@@ -8787,7 +8753,7 @@
               <a:pPr/>
               <a:t>‹#›</a:t>
             </a:fld>
-            <a:endParaRPr lang="en-US" dirty="0"/>
+            <a:endParaRPr lang="en-US"/>
           </a:p>
         </p:txBody>
       </p:sp>
@@ -8969,7 +8935,7 @@
           </a:lstStyle>
           <a:p>
             <a:r>
-              <a:rPr lang="en-US" dirty="0"/>
+              <a:rPr lang="en-US"/>
               <a:t>Click to edit Master title style</a:t>
             </a:r>
           </a:p>
@@ -9073,7 +9039,6 @@
               <a:rPr lang="en-US"/>
               <a:t>Fifth level</a:t>
             </a:r>
-            <a:endParaRPr lang="en-US" dirty="0"/>
           </a:p>
         </p:txBody>
       </p:sp>
@@ -9119,7 +9084,6 @@
               <a:rPr lang="en-US"/>
               <a:t>Presentation title</a:t>
             </a:r>
-            <a:endParaRPr lang="en-US" dirty="0"/>
           </a:p>
         </p:txBody>
       </p:sp>
@@ -9164,7 +9128,7 @@
               <a:rPr lang="en-US" smtClean="0"/>
               <a:t>5/3/2026</a:t>
             </a:fld>
-            <a:endParaRPr lang="en-US" dirty="0"/>
+            <a:endParaRPr lang="en-US"/>
           </a:p>
         </p:txBody>
       </p:sp>
@@ -9211,7 +9175,7 @@
               <a:pPr/>
               <a:t>‹#›</a:t>
             </a:fld>
-            <a:endParaRPr lang="en-US" dirty="0"/>
+            <a:endParaRPr lang="en-US"/>
           </a:p>
         </p:txBody>
       </p:sp>
@@ -9259,7 +9223,7 @@
           </a:lstStyle>
           <a:p>
             <a:r>
-              <a:rPr lang="en-US" dirty="0"/>
+              <a:rPr lang="en-US"/>
               <a:t> </a:t>
             </a:r>
           </a:p>
@@ -9439,7 +9403,7 @@
           </a:lstStyle>
           <a:p>
             <a:r>
-              <a:rPr lang="en-US" dirty="0"/>
+              <a:rPr lang="en-US"/>
               <a:t>Click to edit Master title style</a:t>
             </a:r>
           </a:p>
@@ -9489,7 +9453,7 @@
           </a:lstStyle>
           <a:p>
             <a:r>
-              <a:rPr lang="en-US" dirty="0"/>
+              <a:rPr lang="en-US"/>
               <a:t> </a:t>
             </a:r>
           </a:p>
@@ -9557,7 +9521,6 @@
               <a:rPr lang="en-US"/>
               <a:t>Fifth level</a:t>
             </a:r>
-            <a:endParaRPr lang="en-US" dirty="0"/>
           </a:p>
         </p:txBody>
       </p:sp>
@@ -9602,7 +9565,6 @@
               <a:rPr lang="en-US"/>
               <a:t>Presentation title</a:t>
             </a:r>
-            <a:endParaRPr lang="en-US" dirty="0"/>
           </a:p>
         </p:txBody>
       </p:sp>
@@ -9647,7 +9609,7 @@
               <a:rPr lang="en-US" smtClean="0"/>
               <a:t>5/3/2026</a:t>
             </a:fld>
-            <a:endParaRPr lang="en-US" dirty="0"/>
+            <a:endParaRPr lang="en-US"/>
           </a:p>
         </p:txBody>
       </p:sp>
@@ -9875,7 +9837,7 @@
           </a:lstStyle>
           <a:p>
             <a:r>
-              <a:rPr lang="en-US" dirty="0"/>
+              <a:rPr lang="en-US"/>
               <a:t>Click to edit Master title style</a:t>
             </a:r>
           </a:p>
@@ -9979,7 +9941,6 @@
               <a:rPr lang="en-US"/>
               <a:t>Fifth level</a:t>
             </a:r>
-            <a:endParaRPr lang="en-US" dirty="0"/>
           </a:p>
         </p:txBody>
       </p:sp>
@@ -10024,7 +9985,6 @@
               <a:rPr lang="en-US"/>
               <a:t>Presentation title</a:t>
             </a:r>
-            <a:endParaRPr lang="en-US" dirty="0"/>
           </a:p>
         </p:txBody>
       </p:sp>
@@ -10069,7 +10029,7 @@
               <a:rPr lang="en-US" smtClean="0"/>
               <a:t>5/3/2026</a:t>
             </a:fld>
-            <a:endParaRPr lang="en-US" dirty="0"/>
+            <a:endParaRPr lang="en-US"/>
           </a:p>
         </p:txBody>
       </p:sp>
@@ -10163,7 +10123,7 @@
           </a:lstStyle>
           <a:p>
             <a:r>
-              <a:rPr lang="en-US" dirty="0"/>
+              <a:rPr lang="en-US"/>
               <a:t> </a:t>
             </a:r>
           </a:p>
@@ -10345,7 +10305,7 @@
           </a:lstStyle>
           <a:p>
             <a:r>
-              <a:rPr lang="en-US" dirty="0"/>
+              <a:rPr lang="en-US"/>
               <a:t>Click to edit Master title style</a:t>
             </a:r>
           </a:p>
@@ -10440,7 +10400,7 @@
           </a:lstStyle>
           <a:p>
             <a:r>
-              <a:rPr lang="en-US" dirty="0"/>
+              <a:rPr lang="en-US"/>
               <a:t> </a:t>
             </a:r>
           </a:p>
@@ -10551,7 +10511,6 @@
               <a:rPr lang="en-US"/>
               <a:t>Fifth level</a:t>
             </a:r>
-            <a:endParaRPr lang="en-US" dirty="0"/>
           </a:p>
         </p:txBody>
       </p:sp>
@@ -10596,7 +10555,6 @@
               <a:rPr lang="en-US"/>
               <a:t>Presentation title</a:t>
             </a:r>
-            <a:endParaRPr lang="en-US" dirty="0"/>
           </a:p>
         </p:txBody>
       </p:sp>
@@ -10642,7 +10600,7 @@
               <a:rPr lang="en-US" smtClean="0"/>
               <a:t>5/3/2026</a:t>
             </a:fld>
-            <a:endParaRPr lang="en-US" dirty="0"/>
+            <a:endParaRPr lang="en-US"/>
           </a:p>
         </p:txBody>
       </p:sp>
@@ -10688,7 +10646,7 @@
               <a:pPr/>
               <a:t>‹#›</a:t>
             </a:fld>
-            <a:endParaRPr lang="en-US" dirty="0"/>
+            <a:endParaRPr lang="en-US"/>
           </a:p>
         </p:txBody>
       </p:sp>
@@ -10856,7 +10814,7 @@
           <a:p>
             <a:pPr lvl="0"/>
             <a:r>
-              <a:rPr lang="en-US" dirty="0"/>
+              <a:rPr lang="en-US"/>
               <a:t>Click to edit Master title style</a:t>
             </a:r>
           </a:p>
@@ -10906,7 +10864,6 @@
               <a:rPr lang="en-US"/>
               <a:t>Click to edit Master subtitle style</a:t>
             </a:r>
-            <a:endParaRPr lang="en-US" dirty="0"/>
           </a:p>
         </p:txBody>
       </p:sp>
@@ -10943,7 +10900,6 @@
               <a:rPr lang="en-US"/>
               <a:t>Presentation title</a:t>
             </a:r>
-            <a:endParaRPr lang="en-US" dirty="0"/>
           </a:p>
         </p:txBody>
       </p:sp>
@@ -10980,7 +10936,7 @@
               <a:rPr lang="en-US" smtClean="0"/>
               <a:t>5/3/2026</a:t>
             </a:fld>
-            <a:endParaRPr lang="en-US" dirty="0"/>
+            <a:endParaRPr lang="en-US"/>
           </a:p>
         </p:txBody>
       </p:sp>
@@ -11017,7 +10973,7 @@
               <a:rPr lang="en-US" smtClean="0"/>
               <a:t>‹#›</a:t>
             </a:fld>
-            <a:endParaRPr lang="en-US" dirty="0"/>
+            <a:endParaRPr lang="en-US"/>
           </a:p>
         </p:txBody>
       </p:sp>
@@ -11168,7 +11124,7 @@
           </a:lstStyle>
           <a:p>
             <a:r>
-              <a:rPr lang="en-US" dirty="0"/>
+              <a:rPr lang="en-US"/>
               <a:t>Click to edit Master title style</a:t>
             </a:r>
           </a:p>
@@ -11279,7 +11235,6 @@
               <a:rPr lang="en-US"/>
               <a:t>Fifth level</a:t>
             </a:r>
-            <a:endParaRPr lang="en-US" dirty="0"/>
           </a:p>
         </p:txBody>
       </p:sp>
@@ -11324,7 +11279,6 @@
               <a:rPr lang="en-US"/>
               <a:t>Presentation title</a:t>
             </a:r>
-            <a:endParaRPr lang="en-US" dirty="0"/>
           </a:p>
         </p:txBody>
       </p:sp>
@@ -11370,7 +11324,7 @@
               <a:rPr lang="en-US" smtClean="0"/>
               <a:t>5/3/2026</a:t>
             </a:fld>
-            <a:endParaRPr lang="en-US" dirty="0"/>
+            <a:endParaRPr lang="en-US"/>
           </a:p>
         </p:txBody>
       </p:sp>
@@ -11416,7 +11370,7 @@
               <a:pPr/>
               <a:t>‹#›</a:t>
             </a:fld>
-            <a:endParaRPr lang="en-US" dirty="0"/>
+            <a:endParaRPr lang="en-US"/>
           </a:p>
         </p:txBody>
       </p:sp>
@@ -11509,7 +11463,7 @@
           </a:lstStyle>
           <a:p>
             <a:r>
-              <a:rPr lang="en-US" dirty="0"/>
+              <a:rPr lang="en-US"/>
               <a:t> </a:t>
             </a:r>
           </a:p>
@@ -11693,7 +11647,7 @@
           </a:lstStyle>
           <a:p>
             <a:r>
-              <a:rPr lang="en-US" dirty="0"/>
+              <a:rPr lang="en-US"/>
               <a:t>Click to edit Master title style</a:t>
             </a:r>
           </a:p>
@@ -11743,7 +11697,7 @@
           </a:lstStyle>
           <a:p>
             <a:r>
-              <a:rPr lang="en-US" dirty="0"/>
+              <a:rPr lang="en-US"/>
               <a:t> </a:t>
             </a:r>
           </a:p>
@@ -11854,7 +11808,6 @@
               <a:rPr lang="en-US"/>
               <a:t>Fifth level</a:t>
             </a:r>
-            <a:endParaRPr lang="en-US" dirty="0"/>
           </a:p>
         </p:txBody>
       </p:sp>
@@ -11899,7 +11852,6 @@
               <a:rPr lang="en-US"/>
               <a:t>Presentation title</a:t>
             </a:r>
-            <a:endParaRPr lang="en-US" dirty="0"/>
           </a:p>
         </p:txBody>
       </p:sp>
@@ -11944,7 +11896,7 @@
               <a:rPr lang="en-US" smtClean="0"/>
               <a:t>5/3/2026</a:t>
             </a:fld>
-            <a:endParaRPr lang="en-US" dirty="0"/>
+            <a:endParaRPr lang="en-US"/>
           </a:p>
         </p:txBody>
       </p:sp>
@@ -11990,7 +11942,7 @@
               <a:pPr/>
               <a:t>‹#›</a:t>
             </a:fld>
-            <a:endParaRPr lang="en-US" dirty="0"/>
+            <a:endParaRPr lang="en-US"/>
           </a:p>
         </p:txBody>
       </p:sp>
@@ -12075,7 +12027,7 @@
           </a:lstStyle>
           <a:p>
             <a:r>
-              <a:rPr lang="en-US" dirty="0"/>
+              <a:rPr lang="en-US"/>
               <a:t>Click to edit Master title style</a:t>
             </a:r>
           </a:p>
@@ -12125,7 +12077,7 @@
           </a:lstStyle>
           <a:p>
             <a:r>
-              <a:rPr lang="en-US" dirty="0"/>
+              <a:rPr lang="en-US"/>
               <a:t> </a:t>
             </a:r>
           </a:p>
@@ -12236,7 +12188,6 @@
               <a:rPr lang="en-US"/>
               <a:t>Fifth level</a:t>
             </a:r>
-            <a:endParaRPr lang="en-US" dirty="0"/>
           </a:p>
         </p:txBody>
       </p:sp>
@@ -12281,7 +12232,6 @@
               <a:rPr lang="en-US"/>
               <a:t>Presentation title</a:t>
             </a:r>
-            <a:endParaRPr lang="en-US" dirty="0"/>
           </a:p>
         </p:txBody>
       </p:sp>
@@ -12326,7 +12276,7 @@
               <a:rPr lang="en-US" smtClean="0"/>
               <a:t>5/3/2026</a:t>
             </a:fld>
-            <a:endParaRPr lang="en-US" dirty="0"/>
+            <a:endParaRPr lang="en-US"/>
           </a:p>
         </p:txBody>
       </p:sp>
@@ -12372,7 +12322,7 @@
               <a:pPr/>
               <a:t>‹#›</a:t>
             </a:fld>
-            <a:endParaRPr lang="en-US" dirty="0"/>
+            <a:endParaRPr lang="en-US"/>
           </a:p>
         </p:txBody>
       </p:sp>
@@ -12457,7 +12407,7 @@
           </a:lstStyle>
           <a:p>
             <a:r>
-              <a:rPr lang="en-US" dirty="0"/>
+              <a:rPr lang="en-US"/>
               <a:t>Click to edit Master title style</a:t>
             </a:r>
           </a:p>
@@ -12504,7 +12454,6 @@
               <a:rPr lang="en-US"/>
               <a:t>Presentation title</a:t>
             </a:r>
-            <a:endParaRPr lang="en-US" dirty="0"/>
           </a:p>
         </p:txBody>
       </p:sp>
@@ -12549,7 +12498,7 @@
               <a:rPr lang="en-US" smtClean="0"/>
               <a:t>5/3/2026</a:t>
             </a:fld>
-            <a:endParaRPr lang="en-US" dirty="0"/>
+            <a:endParaRPr lang="en-US"/>
           </a:p>
         </p:txBody>
       </p:sp>
@@ -12595,7 +12544,7 @@
               <a:pPr/>
               <a:t>‹#›</a:t>
             </a:fld>
-            <a:endParaRPr lang="en-US" dirty="0"/>
+            <a:endParaRPr lang="en-US"/>
           </a:p>
         </p:txBody>
       </p:sp>
@@ -12704,7 +12653,6 @@
               <a:rPr lang="en-US"/>
               <a:t>Fifth level</a:t>
             </a:r>
-            <a:endParaRPr lang="en-US" dirty="0"/>
           </a:p>
         </p:txBody>
       </p:sp>
@@ -12752,7 +12700,7 @@
           </a:lstStyle>
           <a:p>
             <a:r>
-              <a:rPr lang="en-US" dirty="0"/>
+              <a:rPr lang="en-US"/>
               <a:t> </a:t>
             </a:r>
           </a:p>
@@ -12837,7 +12785,7 @@
           </a:lstStyle>
           <a:p>
             <a:r>
-              <a:rPr lang="en-US" dirty="0"/>
+              <a:rPr lang="en-US"/>
               <a:t>Click to edit Master title style</a:t>
             </a:r>
           </a:p>
@@ -12941,7 +12889,6 @@
               <a:rPr lang="en-US"/>
               <a:t>Fifth level</a:t>
             </a:r>
-            <a:endParaRPr lang="en-US" dirty="0"/>
           </a:p>
         </p:txBody>
       </p:sp>
@@ -12986,7 +12933,6 @@
               <a:rPr lang="en-US"/>
               <a:t>Presentation title</a:t>
             </a:r>
-            <a:endParaRPr lang="en-US" dirty="0"/>
           </a:p>
         </p:txBody>
       </p:sp>
@@ -13031,7 +12977,7 @@
               <a:rPr lang="en-US" smtClean="0"/>
               <a:t>5/3/2026</a:t>
             </a:fld>
-            <a:endParaRPr lang="en-US" dirty="0"/>
+            <a:endParaRPr lang="en-US"/>
           </a:p>
         </p:txBody>
       </p:sp>
@@ -13077,7 +13023,7 @@
               <a:pPr/>
               <a:t>‹#›</a:t>
             </a:fld>
-            <a:endParaRPr lang="en-US" dirty="0"/>
+            <a:endParaRPr lang="en-US"/>
           </a:p>
         </p:txBody>
       </p:sp>
@@ -13171,7 +13117,7 @@
           <a:p>
             <a:pPr marL="228600" lvl="0" indent="-228600"/>
             <a:r>
-              <a:rPr lang="en-US" dirty="0"/>
+              <a:rPr lang="en-US"/>
               <a:t> </a:t>
             </a:r>
           </a:p>
@@ -13360,7 +13306,7 @@
           </a:lstStyle>
           <a:p>
             <a:r>
-              <a:rPr lang="en-US" dirty="0"/>
+              <a:rPr lang="en-US"/>
               <a:t>Click to edit Master title style</a:t>
             </a:r>
           </a:p>
@@ -13464,7 +13410,6 @@
               <a:rPr lang="en-US"/>
               <a:t>Fifth level</a:t>
             </a:r>
-            <a:endParaRPr lang="en-US" dirty="0"/>
           </a:p>
         </p:txBody>
       </p:sp>
@@ -13558,7 +13503,7 @@
           <a:p>
             <a:pPr marL="228600" lvl="0" indent="-228600"/>
             <a:r>
-              <a:rPr lang="en-US" dirty="0"/>
+              <a:rPr lang="en-US"/>
               <a:t> </a:t>
             </a:r>
           </a:p>
@@ -13605,7 +13550,6 @@
               <a:rPr lang="en-US"/>
               <a:t>Presentation title</a:t>
             </a:r>
-            <a:endParaRPr lang="en-US" dirty="0"/>
           </a:p>
         </p:txBody>
       </p:sp>
@@ -13650,7 +13594,7 @@
               <a:rPr lang="en-US" smtClean="0"/>
               <a:t>5/3/2026</a:t>
             </a:fld>
-            <a:endParaRPr lang="en-US" dirty="0"/>
+            <a:endParaRPr lang="en-US"/>
           </a:p>
         </p:txBody>
       </p:sp>
@@ -13696,7 +13640,7 @@
               <a:pPr/>
               <a:t>‹#›</a:t>
             </a:fld>
-            <a:endParaRPr lang="en-US" dirty="0"/>
+            <a:endParaRPr lang="en-US"/>
           </a:p>
         </p:txBody>
       </p:sp>
@@ -13779,7 +13723,7 @@
           </a:lstStyle>
           <a:p>
             <a:r>
-              <a:rPr lang="en-US" dirty="0"/>
+              <a:rPr lang="en-US"/>
               <a:t>Click to edit Master title style</a:t>
             </a:r>
           </a:p>
@@ -13875,7 +13819,7 @@
           <a:p>
             <a:pPr marL="228600" lvl="0" indent="-228600"/>
             <a:r>
-              <a:rPr lang="en-US" dirty="0"/>
+              <a:rPr lang="en-US"/>
               <a:t> </a:t>
             </a:r>
           </a:p>
@@ -13979,7 +13923,6 @@
               <a:rPr lang="en-US"/>
               <a:t>Fifth level</a:t>
             </a:r>
-            <a:endParaRPr lang="en-US" dirty="0"/>
           </a:p>
         </p:txBody>
       </p:sp>
@@ -14024,7 +13967,6 @@
               <a:rPr lang="en-US"/>
               <a:t>Presentation title</a:t>
             </a:r>
-            <a:endParaRPr lang="en-US" dirty="0"/>
           </a:p>
         </p:txBody>
       </p:sp>
@@ -14069,7 +14011,7 @@
               <a:rPr lang="en-US" smtClean="0"/>
               <a:t>5/3/2026</a:t>
             </a:fld>
-            <a:endParaRPr lang="en-US" dirty="0"/>
+            <a:endParaRPr lang="en-US"/>
           </a:p>
         </p:txBody>
       </p:sp>
@@ -14115,7 +14057,7 @@
               <a:pPr/>
               <a:t>‹#›</a:t>
             </a:fld>
-            <a:endParaRPr lang="en-US" dirty="0"/>
+            <a:endParaRPr lang="en-US"/>
           </a:p>
         </p:txBody>
       </p:sp>
@@ -14252,7 +14194,7 @@
           </a:lstStyle>
           <a:p>
             <a:r>
-              <a:rPr lang="en-US" dirty="0"/>
+              <a:rPr lang="en-US"/>
               <a:t>Click to edit Master title style</a:t>
             </a:r>
           </a:p>
@@ -14303,7 +14245,7 @@
           </a:lstStyle>
           <a:p>
             <a:r>
-              <a:rPr lang="en-US" dirty="0"/>
+              <a:rPr lang="en-US"/>
               <a:t> </a:t>
             </a:r>
           </a:p>
@@ -14407,7 +14349,6 @@
               <a:rPr lang="en-US"/>
               <a:t>Fifth level</a:t>
             </a:r>
-            <a:endParaRPr lang="en-US" dirty="0"/>
           </a:p>
         </p:txBody>
       </p:sp>
@@ -14452,7 +14393,6 @@
               <a:rPr lang="en-US"/>
               <a:t>Presentation title</a:t>
             </a:r>
-            <a:endParaRPr lang="en-US" dirty="0"/>
           </a:p>
         </p:txBody>
       </p:sp>
@@ -14497,7 +14437,7 @@
               <a:rPr lang="en-US" smtClean="0"/>
               <a:t>5/3/2026</a:t>
             </a:fld>
-            <a:endParaRPr lang="en-US" dirty="0"/>
+            <a:endParaRPr lang="en-US"/>
           </a:p>
         </p:txBody>
       </p:sp>
@@ -14732,7 +14672,7 @@
           </a:lstStyle>
           <a:p>
             <a:r>
-              <a:rPr lang="en-US" dirty="0"/>
+              <a:rPr lang="en-US"/>
               <a:t>Click to edit Master title style</a:t>
             </a:r>
           </a:p>
@@ -14783,7 +14723,7 @@
           </a:lstStyle>
           <a:p>
             <a:r>
-              <a:rPr lang="en-US" dirty="0"/>
+              <a:rPr lang="en-US"/>
               <a:t> </a:t>
             </a:r>
           </a:p>
@@ -14887,7 +14827,6 @@
               <a:rPr lang="en-US"/>
               <a:t>Fifth level</a:t>
             </a:r>
-            <a:endParaRPr lang="en-US" dirty="0"/>
           </a:p>
         </p:txBody>
       </p:sp>
@@ -14932,7 +14871,6 @@
               <a:rPr lang="en-US"/>
               <a:t>Presentation title</a:t>
             </a:r>
-            <a:endParaRPr lang="en-US" dirty="0"/>
           </a:p>
         </p:txBody>
       </p:sp>
@@ -14977,7 +14915,7 @@
               <a:rPr lang="en-US" smtClean="0"/>
               <a:t>5/3/2026</a:t>
             </a:fld>
-            <a:endParaRPr lang="en-US" dirty="0"/>
+            <a:endParaRPr lang="en-US"/>
           </a:p>
         </p:txBody>
       </p:sp>
@@ -15023,7 +14961,7 @@
               <a:pPr/>
               <a:t>‹#›</a:t>
             </a:fld>
-            <a:endParaRPr lang="en-US" dirty="0"/>
+            <a:endParaRPr lang="en-US"/>
           </a:p>
         </p:txBody>
       </p:sp>
@@ -15206,7 +15144,7 @@
           </a:lstStyle>
           <a:p>
             <a:r>
-              <a:rPr lang="en-US" dirty="0"/>
+              <a:rPr lang="en-US"/>
               <a:t>Click to edit Master title style</a:t>
             </a:r>
           </a:p>
@@ -15251,7 +15189,7 @@
           <a:p>
             <a:pPr lvl="0"/>
             <a:r>
-              <a:rPr lang="en-US" dirty="0"/>
+              <a:rPr lang="en-US"/>
               <a:t>##%</a:t>
             </a:r>
           </a:p>
@@ -15298,7 +15236,6 @@
               <a:rPr lang="en-US"/>
               <a:t>Presentation title</a:t>
             </a:r>
-            <a:endParaRPr lang="en-US" dirty="0"/>
           </a:p>
         </p:txBody>
       </p:sp>
@@ -15343,7 +15280,7 @@
               <a:rPr lang="en-US" smtClean="0"/>
               <a:t>5/3/2026</a:t>
             </a:fld>
-            <a:endParaRPr lang="en-US" dirty="0"/>
+            <a:endParaRPr lang="en-US"/>
           </a:p>
         </p:txBody>
       </p:sp>
@@ -15389,7 +15326,7 @@
               <a:pPr/>
               <a:t>‹#›</a:t>
             </a:fld>
-            <a:endParaRPr lang="en-US" dirty="0"/>
+            <a:endParaRPr lang="en-US"/>
           </a:p>
         </p:txBody>
       </p:sp>
@@ -15574,7 +15511,7 @@
           </a:lstStyle>
           <a:p>
             <a:r>
-              <a:rPr lang="en-US" dirty="0"/>
+              <a:rPr lang="en-US"/>
               <a:t>Click to edit Master title style</a:t>
             </a:r>
           </a:p>
@@ -15621,7 +15558,7 @@
           <a:p>
             <a:pPr lvl="0"/>
             <a:r>
-              <a:rPr lang="en-US" dirty="0"/>
+              <a:rPr lang="en-US"/>
               <a:t>Click to edit Master subtitle style</a:t>
             </a:r>
           </a:p>
@@ -15660,7 +15597,6 @@
               <a:rPr lang="en-US"/>
               <a:t>Presentation title</a:t>
             </a:r>
-            <a:endParaRPr lang="en-US" dirty="0"/>
           </a:p>
         </p:txBody>
       </p:sp>
@@ -15697,7 +15633,7 @@
               <a:rPr lang="en-US" smtClean="0"/>
               <a:t>5/3/2026</a:t>
             </a:fld>
-            <a:endParaRPr lang="en-US" dirty="0"/>
+            <a:endParaRPr lang="en-US"/>
           </a:p>
         </p:txBody>
       </p:sp>
@@ -15734,7 +15670,7 @@
               <a:rPr lang="en-US" smtClean="0"/>
               <a:t>‹#›</a:t>
             </a:fld>
-            <a:endParaRPr lang="en-US" dirty="0"/>
+            <a:endParaRPr lang="en-US"/>
           </a:p>
         </p:txBody>
       </p:sp>
@@ -15880,7 +15816,7 @@
           </a:lstStyle>
           <a:p>
             <a:r>
-              <a:rPr lang="en-US" dirty="0"/>
+              <a:rPr lang="en-US"/>
               <a:t>Click to edit Master title style</a:t>
             </a:r>
           </a:p>
@@ -15921,7 +15857,7 @@
           <a:p>
             <a:pPr lvl="0"/>
             <a:r>
-              <a:rPr lang="en-US" dirty="0"/>
+              <a:rPr lang="en-US"/>
               <a:t>##%</a:t>
             </a:r>
           </a:p>
@@ -15968,7 +15904,6 @@
               <a:rPr lang="en-US"/>
               <a:t>Presentation title</a:t>
             </a:r>
-            <a:endParaRPr lang="en-US" dirty="0"/>
           </a:p>
         </p:txBody>
       </p:sp>
@@ -16241,7 +16176,7 @@
           </a:lstStyle>
           <a:p>
             <a:r>
-              <a:rPr lang="en-US" dirty="0"/>
+              <a:rPr lang="en-US"/>
               <a:t>Click to edit Master title style</a:t>
             </a:r>
           </a:p>
@@ -16282,7 +16217,7 @@
           <a:p>
             <a:pPr lvl="0"/>
             <a:r>
-              <a:rPr lang="en-US" dirty="0"/>
+              <a:rPr lang="en-US"/>
               <a:t>##%</a:t>
             </a:r>
           </a:p>
@@ -16329,7 +16264,6 @@
               <a:rPr lang="en-US"/>
               <a:t>Presentation title</a:t>
             </a:r>
-            <a:endParaRPr lang="en-US" dirty="0"/>
           </a:p>
         </p:txBody>
       </p:sp>
@@ -16374,7 +16308,7 @@
               <a:rPr lang="en-US" smtClean="0"/>
               <a:t>5/3/2026</a:t>
             </a:fld>
-            <a:endParaRPr lang="en-US" dirty="0"/>
+            <a:endParaRPr lang="en-US"/>
           </a:p>
         </p:txBody>
       </p:sp>
@@ -16420,7 +16354,7 @@
               <a:pPr/>
               <a:t>‹#›</a:t>
             </a:fld>
-            <a:endParaRPr lang="en-US" dirty="0"/>
+            <a:endParaRPr lang="en-US"/>
           </a:p>
         </p:txBody>
       </p:sp>
@@ -16661,7 +16595,7 @@
           </a:lstStyle>
           <a:p>
             <a:r>
-              <a:rPr lang="en-US" dirty="0"/>
+              <a:rPr lang="en-US"/>
               <a:t>Click to edit Master title style</a:t>
             </a:r>
           </a:p>
@@ -16781,35 +16715,35 @@
           <a:p>
             <a:pPr lvl="0"/>
             <a:r>
-              <a:rPr lang="en-US" dirty="0"/>
+              <a:rPr lang="en-US"/>
               <a:t>Click to add Statement</a:t>
             </a:r>
           </a:p>
           <a:p>
             <a:pPr lvl="1"/>
             <a:r>
-              <a:rPr lang="en-US" dirty="0"/>
+              <a:rPr lang="en-US"/>
               <a:t>Second level</a:t>
             </a:r>
           </a:p>
           <a:p>
             <a:pPr lvl="2"/>
             <a:r>
-              <a:rPr lang="en-US" dirty="0"/>
+              <a:rPr lang="en-US"/>
               <a:t>Third level</a:t>
             </a:r>
           </a:p>
           <a:p>
             <a:pPr lvl="3"/>
             <a:r>
-              <a:rPr lang="en-US" dirty="0"/>
+              <a:rPr lang="en-US"/>
               <a:t>Fourth level</a:t>
             </a:r>
           </a:p>
           <a:p>
             <a:pPr lvl="4"/>
             <a:r>
-              <a:rPr lang="en-US" dirty="0"/>
+              <a:rPr lang="en-US"/>
               <a:t>Fifth level</a:t>
             </a:r>
           </a:p>
@@ -16900,7 +16834,7 @@
               <a:rPr lang="en-US" smtClean="0"/>
               <a:t>5/3/2026</a:t>
             </a:fld>
-            <a:endParaRPr lang="en-US" dirty="0"/>
+            <a:endParaRPr lang="en-US"/>
           </a:p>
         </p:txBody>
       </p:sp>
@@ -16946,7 +16880,7 @@
               <a:pPr/>
               <a:t>‹#›</a:t>
             </a:fld>
-            <a:endParaRPr lang="en-US" dirty="0"/>
+            <a:endParaRPr lang="en-US"/>
           </a:p>
         </p:txBody>
       </p:sp>
@@ -17122,7 +17056,7 @@
           </a:lstStyle>
           <a:p>
             <a:r>
-              <a:rPr lang="en-US" dirty="0"/>
+              <a:rPr lang="en-US"/>
               <a:t>Click to edit Master title style</a:t>
             </a:r>
           </a:p>
@@ -17232,35 +17166,35 @@
           <a:p>
             <a:pPr lvl="0"/>
             <a:r>
-              <a:rPr lang="en-US" dirty="0"/>
+              <a:rPr lang="en-US"/>
               <a:t>Click to add Statement</a:t>
             </a:r>
           </a:p>
           <a:p>
             <a:pPr lvl="1"/>
             <a:r>
-              <a:rPr lang="en-US" dirty="0"/>
+              <a:rPr lang="en-US"/>
               <a:t>Second level</a:t>
             </a:r>
           </a:p>
           <a:p>
             <a:pPr lvl="2"/>
             <a:r>
-              <a:rPr lang="en-US" dirty="0"/>
+              <a:rPr lang="en-US"/>
               <a:t>Third level</a:t>
             </a:r>
           </a:p>
           <a:p>
             <a:pPr lvl="3"/>
             <a:r>
-              <a:rPr lang="en-US" dirty="0"/>
+              <a:rPr lang="en-US"/>
               <a:t>Fourth level</a:t>
             </a:r>
           </a:p>
           <a:p>
             <a:pPr lvl="4"/>
             <a:r>
-              <a:rPr lang="en-US" dirty="0"/>
+              <a:rPr lang="en-US"/>
               <a:t>Fifth level</a:t>
             </a:r>
           </a:p>
@@ -17299,7 +17233,6 @@
               <a:rPr lang="en-US"/>
               <a:t>Presentation title</a:t>
             </a:r>
-            <a:endParaRPr lang="en-US" dirty="0"/>
           </a:p>
         </p:txBody>
       </p:sp>
@@ -17336,7 +17269,7 @@
               <a:rPr lang="en-US" smtClean="0"/>
               <a:t>5/3/2026</a:t>
             </a:fld>
-            <a:endParaRPr lang="en-US" dirty="0"/>
+            <a:endParaRPr lang="en-US"/>
           </a:p>
         </p:txBody>
       </p:sp>
@@ -17373,7 +17306,7 @@
               <a:rPr lang="en-US" smtClean="0"/>
               <a:t>‹#›</a:t>
             </a:fld>
-            <a:endParaRPr lang="en-US" dirty="0"/>
+            <a:endParaRPr lang="en-US"/>
           </a:p>
         </p:txBody>
       </p:sp>
@@ -17560,7 +17493,7 @@
           </a:lstStyle>
           <a:p>
             <a:r>
-              <a:rPr lang="en-US" dirty="0"/>
+              <a:rPr lang="en-US"/>
               <a:t>Click to edit Master title style</a:t>
             </a:r>
           </a:p>
@@ -17670,35 +17603,35 @@
           <a:p>
             <a:pPr lvl="0"/>
             <a:r>
-              <a:rPr lang="en-US" dirty="0"/>
+              <a:rPr lang="en-US"/>
               <a:t>Click to add Statement</a:t>
             </a:r>
           </a:p>
           <a:p>
             <a:pPr lvl="1"/>
             <a:r>
-              <a:rPr lang="en-US" dirty="0"/>
+              <a:rPr lang="en-US"/>
               <a:t>Second level</a:t>
             </a:r>
           </a:p>
           <a:p>
             <a:pPr lvl="2"/>
             <a:r>
-              <a:rPr lang="en-US" dirty="0"/>
+              <a:rPr lang="en-US"/>
               <a:t>Third level</a:t>
             </a:r>
           </a:p>
           <a:p>
             <a:pPr lvl="3"/>
             <a:r>
-              <a:rPr lang="en-US" dirty="0"/>
+              <a:rPr lang="en-US"/>
               <a:t>Fourth level</a:t>
             </a:r>
           </a:p>
           <a:p>
             <a:pPr lvl="4"/>
             <a:r>
-              <a:rPr lang="en-US" dirty="0"/>
+              <a:rPr lang="en-US"/>
               <a:t>Fifth level</a:t>
             </a:r>
           </a:p>
@@ -17745,7 +17678,6 @@
               <a:rPr lang="en-US"/>
               <a:t>Presentation title</a:t>
             </a:r>
-            <a:endParaRPr lang="en-US" dirty="0"/>
           </a:p>
         </p:txBody>
       </p:sp>
@@ -17790,7 +17722,7 @@
               <a:rPr lang="en-US" smtClean="0"/>
               <a:t>5/3/2026</a:t>
             </a:fld>
-            <a:endParaRPr lang="en-US" dirty="0"/>
+            <a:endParaRPr lang="en-US"/>
           </a:p>
         </p:txBody>
       </p:sp>
@@ -17836,7 +17768,7 @@
               <a:pPr/>
               <a:t>‹#›</a:t>
             </a:fld>
-            <a:endParaRPr lang="en-US" dirty="0"/>
+            <a:endParaRPr lang="en-US"/>
           </a:p>
         </p:txBody>
       </p:sp>
@@ -18033,7 +17965,7 @@
           </a:lstStyle>
           <a:p>
             <a:r>
-              <a:rPr lang="en-US" dirty="0"/>
+              <a:rPr lang="en-US"/>
               <a:t>Quote Author</a:t>
             </a:r>
           </a:p>
@@ -18086,7 +18018,7 @@
           <a:p>
             <a:pPr lvl="0"/>
             <a:r>
-              <a:rPr lang="en-US" dirty="0"/>
+              <a:rPr lang="en-US"/>
               <a:t>Click to add Quote</a:t>
             </a:r>
           </a:p>
@@ -18161,7 +18093,7 @@
               <a:rPr lang="en-US" smtClean="0"/>
               <a:t>5/3/2026</a:t>
             </a:fld>
-            <a:endParaRPr lang="en-US" dirty="0"/>
+            <a:endParaRPr lang="en-US"/>
           </a:p>
         </p:txBody>
       </p:sp>
@@ -18198,7 +18130,7 @@
               <a:rPr lang="en-US" smtClean="0"/>
               <a:t>‹#›</a:t>
             </a:fld>
-            <a:endParaRPr lang="en-US" dirty="0"/>
+            <a:endParaRPr lang="en-US"/>
           </a:p>
         </p:txBody>
       </p:sp>
@@ -18384,7 +18316,7 @@
           </a:lstStyle>
           <a:p>
             <a:r>
-              <a:rPr lang="en-US" dirty="0"/>
+              <a:rPr lang="en-US"/>
               <a:t>Quote Author</a:t>
             </a:r>
           </a:p>
@@ -18440,7 +18372,7 @@
           <a:p>
             <a:pPr lvl="0"/>
             <a:r>
-              <a:rPr lang="en-US" dirty="0"/>
+              <a:rPr lang="en-US"/>
               <a:t>Click to add Quote</a:t>
             </a:r>
           </a:p>
@@ -18531,7 +18463,7 @@
               <a:rPr lang="en-US" smtClean="0"/>
               <a:t>5/3/2026</a:t>
             </a:fld>
-            <a:endParaRPr lang="en-US" dirty="0"/>
+            <a:endParaRPr lang="en-US"/>
           </a:p>
         </p:txBody>
       </p:sp>
@@ -18577,7 +18509,7 @@
               <a:pPr/>
               <a:t>‹#›</a:t>
             </a:fld>
-            <a:endParaRPr lang="en-US" dirty="0"/>
+            <a:endParaRPr lang="en-US"/>
           </a:p>
         </p:txBody>
       </p:sp>
@@ -18752,7 +18684,7 @@
           </a:lstStyle>
           <a:p>
             <a:r>
-              <a:rPr lang="en-US" dirty="0"/>
+              <a:rPr lang="en-US"/>
               <a:t>Quote Author</a:t>
             </a:r>
           </a:p>
@@ -18805,7 +18737,7 @@
           <a:p>
             <a:pPr lvl="0"/>
             <a:r>
-              <a:rPr lang="en-US" dirty="0"/>
+              <a:rPr lang="en-US"/>
               <a:t>Click to add Quote</a:t>
             </a:r>
           </a:p>
@@ -18844,7 +18776,6 @@
               <a:rPr lang="en-US"/>
               <a:t>Presentation title</a:t>
             </a:r>
-            <a:endParaRPr lang="en-US" dirty="0"/>
           </a:p>
         </p:txBody>
       </p:sp>
@@ -18881,7 +18812,7 @@
               <a:rPr lang="en-US" smtClean="0"/>
               <a:t>5/3/2026</a:t>
             </a:fld>
-            <a:endParaRPr lang="en-US" dirty="0"/>
+            <a:endParaRPr lang="en-US"/>
           </a:p>
         </p:txBody>
       </p:sp>
@@ -18918,7 +18849,7 @@
               <a:rPr lang="en-US" smtClean="0"/>
               <a:t>‹#›</a:t>
             </a:fld>
-            <a:endParaRPr lang="en-US" dirty="0"/>
+            <a:endParaRPr lang="en-US"/>
           </a:p>
         </p:txBody>
       </p:sp>
@@ -19052,7 +18983,7 @@
           </a:lstStyle>
           <a:p>
             <a:r>
-              <a:rPr lang="en-US" dirty="0"/>
+              <a:rPr lang="en-US"/>
               <a:t>Click to edit Master title style</a:t>
             </a:r>
           </a:p>
@@ -19120,7 +19051,6 @@
               <a:rPr lang="en-US"/>
               <a:t>Fifth level</a:t>
             </a:r>
-            <a:endParaRPr lang="en-US" dirty="0"/>
           </a:p>
         </p:txBody>
       </p:sp>
@@ -19186,7 +19116,6 @@
               <a:rPr lang="en-US"/>
               <a:t>Fifth level</a:t>
             </a:r>
-            <a:endParaRPr lang="en-US" dirty="0"/>
           </a:p>
         </p:txBody>
       </p:sp>
@@ -19223,7 +19152,6 @@
               <a:rPr lang="en-US"/>
               <a:t>Presentation title</a:t>
             </a:r>
-            <a:endParaRPr lang="en-US" dirty="0"/>
           </a:p>
         </p:txBody>
       </p:sp>
@@ -19480,7 +19408,7 @@
           </a:lstStyle>
           <a:p>
             <a:r>
-              <a:rPr lang="en-US" dirty="0"/>
+              <a:rPr lang="en-US"/>
               <a:t>Click to edit Master title style</a:t>
             </a:r>
           </a:p>
@@ -19627,7 +19555,6 @@
               <a:rPr lang="en-US"/>
               <a:t>Fifth level</a:t>
             </a:r>
-            <a:endParaRPr lang="en-US" dirty="0"/>
           </a:p>
         </p:txBody>
       </p:sp>
@@ -19772,7 +19699,6 @@
               <a:rPr lang="en-US"/>
               <a:t>Fifth level</a:t>
             </a:r>
-            <a:endParaRPr lang="en-US" dirty="0"/>
           </a:p>
         </p:txBody>
       </p:sp>
@@ -19809,7 +19735,6 @@
               <a:rPr lang="en-US"/>
               <a:t>Presentation title</a:t>
             </a:r>
-            <a:endParaRPr lang="en-US" dirty="0"/>
           </a:p>
         </p:txBody>
       </p:sp>
@@ -20067,7 +19992,7 @@
           <a:p>
             <a:pPr lvl="0"/>
             <a:r>
-              <a:rPr lang="en-US" dirty="0"/>
+              <a:rPr lang="en-US"/>
               <a:t>Click to edit Master title style</a:t>
             </a:r>
           </a:p>
@@ -20117,7 +20042,6 @@
               <a:rPr lang="en-US"/>
               <a:t>Click to edit Master subtitle style</a:t>
             </a:r>
-            <a:endParaRPr lang="en-US" dirty="0"/>
           </a:p>
         </p:txBody>
       </p:sp>
@@ -20165,7 +20089,7 @@
           </a:lstStyle>
           <a:p>
             <a:r>
-              <a:rPr lang="en-US" dirty="0"/>
+              <a:rPr lang="en-US"/>
               <a:t> </a:t>
             </a:r>
           </a:p>
@@ -20212,7 +20136,6 @@
               <a:rPr lang="en-US"/>
               <a:t>Presentation title</a:t>
             </a:r>
-            <a:endParaRPr lang="en-US" dirty="0"/>
           </a:p>
         </p:txBody>
       </p:sp>
@@ -20257,7 +20180,7 @@
               <a:rPr lang="en-US" smtClean="0"/>
               <a:t>5/3/2026</a:t>
             </a:fld>
-            <a:endParaRPr lang="en-US" dirty="0"/>
+            <a:endParaRPr lang="en-US"/>
           </a:p>
         </p:txBody>
       </p:sp>
@@ -20303,7 +20226,7 @@
               <a:pPr/>
               <a:t>‹#›</a:t>
             </a:fld>
-            <a:endParaRPr lang="en-US" dirty="0"/>
+            <a:endParaRPr lang="en-US"/>
           </a:p>
         </p:txBody>
       </p:sp>
@@ -20391,7 +20314,7 @@
           </a:lstStyle>
           <a:p>
             <a:r>
-              <a:rPr lang="en-US" dirty="0"/>
+              <a:rPr lang="en-US"/>
               <a:t>Click to edit Master title style</a:t>
             </a:r>
           </a:p>
@@ -20438,7 +20361,6 @@
               <a:rPr lang="en-US"/>
               <a:t>Presentation title</a:t>
             </a:r>
-            <a:endParaRPr lang="en-US" dirty="0"/>
           </a:p>
         </p:txBody>
       </p:sp>
@@ -20703,7 +20625,6 @@
               <a:rPr lang="en-US"/>
               <a:t>Presentation title</a:t>
             </a:r>
-            <a:endParaRPr lang="en-US" dirty="0"/>
           </a:p>
         </p:txBody>
       </p:sp>
@@ -20847,7 +20768,7 @@
           </a:lstStyle>
           <a:p>
             <a:r>
-              <a:rPr lang="en-US" dirty="0"/>
+              <a:rPr lang="en-US"/>
               <a:t>Click to edit Master title style</a:t>
             </a:r>
           </a:p>
@@ -21033,7 +20954,6 @@
               <a:rPr lang="en-US"/>
               <a:t>Fifth level</a:t>
             </a:r>
-            <a:endParaRPr lang="en-US" dirty="0"/>
           </a:p>
         </p:txBody>
       </p:sp>
@@ -21070,7 +20990,6 @@
               <a:rPr lang="en-US"/>
               <a:t>Presentation title</a:t>
             </a:r>
-            <a:endParaRPr lang="en-US" dirty="0"/>
           </a:p>
         </p:txBody>
       </p:sp>
@@ -21321,7 +21240,7 @@
           </a:lstStyle>
           <a:p>
             <a:r>
-              <a:rPr lang="en-US" dirty="0"/>
+              <a:rPr lang="en-US"/>
               <a:t>Click to edit Master title style</a:t>
             </a:r>
           </a:p>
@@ -21481,7 +21400,7 @@
           </a:lstStyle>
           <a:p>
             <a:r>
-              <a:rPr lang="en-US" dirty="0"/>
+              <a:rPr lang="en-US"/>
               <a:t> </a:t>
             </a:r>
           </a:p>
@@ -21593,7 +21512,7 @@
               <a:rPr lang="en-US" smtClean="0"/>
               <a:t>‹#›</a:t>
             </a:fld>
-            <a:endParaRPr lang="en-US" dirty="0"/>
+            <a:endParaRPr lang="en-US"/>
           </a:p>
         </p:txBody>
       </p:sp>
@@ -21779,7 +21698,7 @@
           </a:lstStyle>
           <a:p>
             <a:r>
-              <a:rPr lang="en-US" dirty="0"/>
+              <a:rPr lang="en-US"/>
               <a:t>Click to edit Master title style</a:t>
             </a:r>
           </a:p>
@@ -21888,7 +21807,6 @@
               <a:rPr lang="en-US"/>
               <a:t>Fifth level</a:t>
             </a:r>
-            <a:endParaRPr lang="en-US" dirty="0"/>
           </a:p>
         </p:txBody>
       </p:sp>
@@ -22023,7 +21941,7 @@
               <a:pPr/>
               <a:t>‹#›</a:t>
             </a:fld>
-            <a:endParaRPr lang="en-US" dirty="0"/>
+            <a:endParaRPr lang="en-US"/>
           </a:p>
         </p:txBody>
       </p:sp>
@@ -22213,7 +22131,7 @@
           </a:lstStyle>
           <a:p>
             <a:r>
-              <a:rPr lang="en-US" dirty="0"/>
+              <a:rPr lang="en-US"/>
               <a:t>Click to edit Master title style</a:t>
             </a:r>
           </a:p>
@@ -22334,7 +22252,6 @@
               <a:rPr lang="en-US"/>
               <a:t>Fifth level</a:t>
             </a:r>
-            <a:endParaRPr lang="en-US" dirty="0"/>
           </a:p>
         </p:txBody>
       </p:sp>
@@ -22379,7 +22296,6 @@
               <a:rPr lang="en-US"/>
               <a:t>Presentation title</a:t>
             </a:r>
-            <a:endParaRPr lang="en-US" dirty="0"/>
           </a:p>
         </p:txBody>
       </p:sp>
@@ -22424,7 +22340,7 @@
               <a:rPr lang="en-US" smtClean="0"/>
               <a:t>5/3/2026</a:t>
             </a:fld>
-            <a:endParaRPr lang="en-US" dirty="0"/>
+            <a:endParaRPr lang="en-US"/>
           </a:p>
         </p:txBody>
       </p:sp>
@@ -22712,7 +22628,7 @@
           <a:p>
             <a:pPr lvl="0"/>
             <a:r>
-              <a:rPr lang="en-US" dirty="0"/>
+              <a:rPr lang="en-US"/>
               <a:t>Click to edit Master title style</a:t>
             </a:r>
           </a:p>
@@ -22765,7 +22681,6 @@
               <a:rPr lang="en-US"/>
               <a:t>Click to edit Master subtitle style</a:t>
             </a:r>
-            <a:endParaRPr lang="en-US" dirty="0"/>
           </a:p>
         </p:txBody>
       </p:sp>
@@ -22891,7 +22806,7 @@
           </a:lstStyle>
           <a:p>
             <a:r>
-              <a:rPr lang="en-US" dirty="0"/>
+              <a:rPr lang="en-US"/>
               <a:t> </a:t>
             </a:r>
           </a:p>
@@ -22938,7 +22853,6 @@
               <a:rPr lang="en-US"/>
               <a:t>Presentation title</a:t>
             </a:r>
-            <a:endParaRPr lang="en-US" dirty="0"/>
           </a:p>
         </p:txBody>
       </p:sp>
@@ -22984,7 +22898,7 @@
               <a:rPr lang="en-US" smtClean="0"/>
               <a:t>5/3/2026</a:t>
             </a:fld>
-            <a:endParaRPr lang="en-US" dirty="0"/>
+            <a:endParaRPr lang="en-US"/>
           </a:p>
         </p:txBody>
       </p:sp>
@@ -23030,7 +22944,7 @@
               <a:pPr/>
               <a:t>‹#›</a:t>
             </a:fld>
-            <a:endParaRPr lang="en-US" dirty="0"/>
+            <a:endParaRPr lang="en-US"/>
           </a:p>
         </p:txBody>
       </p:sp>
@@ -23176,7 +23090,7 @@
           <a:p>
             <a:pPr lvl="0"/>
             <a:r>
-              <a:rPr lang="en-US" dirty="0"/>
+              <a:rPr lang="en-US"/>
               <a:t>Click to edit Master title style</a:t>
             </a:r>
           </a:p>
@@ -23229,7 +23143,6 @@
               <a:rPr lang="en-US"/>
               <a:t>Click to edit Master subtitle style</a:t>
             </a:r>
-            <a:endParaRPr lang="en-US" dirty="0"/>
           </a:p>
         </p:txBody>
       </p:sp>
@@ -23355,7 +23268,7 @@
           </a:lstStyle>
           <a:p>
             <a:r>
-              <a:rPr lang="en-US" dirty="0"/>
+              <a:rPr lang="en-US"/>
               <a:t> </a:t>
             </a:r>
           </a:p>
@@ -23402,7 +23315,6 @@
               <a:rPr lang="en-US"/>
               <a:t>Presentation title</a:t>
             </a:r>
-            <a:endParaRPr lang="en-US" dirty="0"/>
           </a:p>
         </p:txBody>
       </p:sp>
@@ -23448,7 +23360,7 @@
               <a:rPr lang="en-US" smtClean="0"/>
               <a:t>5/3/2026</a:t>
             </a:fld>
-            <a:endParaRPr lang="en-US" dirty="0"/>
+            <a:endParaRPr lang="en-US"/>
           </a:p>
         </p:txBody>
       </p:sp>
@@ -23494,7 +23406,7 @@
               <a:pPr/>
               <a:t>‹#›</a:t>
             </a:fld>
-            <a:endParaRPr lang="en-US" dirty="0"/>
+            <a:endParaRPr lang="en-US"/>
           </a:p>
         </p:txBody>
       </p:sp>
@@ -23644,7 +23556,7 @@
           <a:p>
             <a:pPr lvl="0"/>
             <a:r>
-              <a:rPr lang="en-US" dirty="0"/>
+              <a:rPr lang="en-US"/>
               <a:t>Click to edit Master title style</a:t>
             </a:r>
           </a:p>
@@ -23694,7 +23606,6 @@
               <a:rPr lang="en-US"/>
               <a:t>Click to edit Master subtitle style</a:t>
             </a:r>
-            <a:endParaRPr lang="en-US" dirty="0"/>
           </a:p>
         </p:txBody>
       </p:sp>
@@ -23731,7 +23642,6 @@
               <a:rPr lang="en-US"/>
               <a:t>Presentation title</a:t>
             </a:r>
-            <a:endParaRPr lang="en-US" dirty="0"/>
           </a:p>
         </p:txBody>
       </p:sp>
@@ -23768,7 +23678,7 @@
               <a:rPr lang="en-US" smtClean="0"/>
               <a:t>5/3/2026</a:t>
             </a:fld>
-            <a:endParaRPr lang="en-US" dirty="0"/>
+            <a:endParaRPr lang="en-US"/>
           </a:p>
         </p:txBody>
       </p:sp>
@@ -23805,7 +23715,7 @@
               <a:rPr lang="en-US" smtClean="0"/>
               <a:t>‹#›</a:t>
             </a:fld>
-            <a:endParaRPr lang="en-US" dirty="0"/>
+            <a:endParaRPr lang="en-US"/>
           </a:p>
         </p:txBody>
       </p:sp>
@@ -23931,7 +23841,7 @@
           </a:lstStyle>
           <a:p>
             <a:r>
-              <a:rPr lang="en-US" dirty="0"/>
+              <a:rPr lang="en-US"/>
               <a:t> </a:t>
             </a:r>
           </a:p>
@@ -24068,7 +23978,7 @@
           </a:lstStyle>
           <a:p>
             <a:r>
-              <a:rPr lang="en-US" dirty="0"/>
+              <a:rPr lang="en-US"/>
               <a:t>Click to edit Master title style</a:t>
             </a:r>
           </a:p>
@@ -24118,7 +24028,6 @@
               <a:rPr lang="en-US"/>
               <a:t>Click to edit Master subtitle style</a:t>
             </a:r>
-            <a:endParaRPr lang="en-US" dirty="0"/>
           </a:p>
         </p:txBody>
       </p:sp>
@@ -24155,7 +24064,6 @@
               <a:rPr lang="en-US"/>
               <a:t>Presentation title</a:t>
             </a:r>
-            <a:endParaRPr lang="en-US" dirty="0"/>
           </a:p>
         </p:txBody>
       </p:sp>
@@ -24192,7 +24100,7 @@
               <a:rPr lang="en-US" smtClean="0"/>
               <a:t>5/3/2026</a:t>
             </a:fld>
-            <a:endParaRPr lang="en-US" dirty="0"/>
+            <a:endParaRPr lang="en-US"/>
           </a:p>
         </p:txBody>
       </p:sp>
@@ -24229,7 +24137,7 @@
               <a:rPr lang="en-US" smtClean="0"/>
               <a:t>‹#›</a:t>
             </a:fld>
-            <a:endParaRPr lang="en-US" dirty="0"/>
+            <a:endParaRPr lang="en-US"/>
           </a:p>
         </p:txBody>
       </p:sp>
@@ -24354,7 +24262,7 @@
           </a:lstStyle>
           <a:p>
             <a:r>
-              <a:rPr lang="en-US" dirty="0"/>
+              <a:rPr lang="en-US"/>
               <a:t> </a:t>
             </a:r>
           </a:p>
@@ -24498,7 +24406,7 @@
           <a:lstStyle/>
           <a:p>
             <a:r>
-              <a:rPr lang="en-US" dirty="0"/>
+              <a:rPr lang="en-US"/>
               <a:t>Click to edit Master title style</a:t>
             </a:r>
           </a:p>
@@ -24537,35 +24445,35 @@
           <a:p>
             <a:pPr lvl="0"/>
             <a:r>
-              <a:rPr lang="en-US" dirty="0"/>
+              <a:rPr lang="en-US"/>
               <a:t>Click to edit Master text styles</a:t>
             </a:r>
           </a:p>
           <a:p>
             <a:pPr lvl="1"/>
             <a:r>
-              <a:rPr lang="en-US" dirty="0"/>
+              <a:rPr lang="en-US"/>
               <a:t>Second level</a:t>
             </a:r>
           </a:p>
           <a:p>
             <a:pPr lvl="2"/>
             <a:r>
-              <a:rPr lang="en-US" dirty="0"/>
+              <a:rPr lang="en-US"/>
               <a:t>Third level</a:t>
             </a:r>
           </a:p>
           <a:p>
             <a:pPr lvl="3"/>
             <a:r>
-              <a:rPr lang="en-US" dirty="0"/>
+              <a:rPr lang="en-US"/>
               <a:t>Fourth level</a:t>
             </a:r>
           </a:p>
           <a:p>
             <a:pPr lvl="4"/>
             <a:r>
-              <a:rPr lang="en-US" dirty="0"/>
+              <a:rPr lang="en-US"/>
               <a:t>Fifth level</a:t>
             </a:r>
           </a:p>
@@ -24614,7 +24522,6 @@
               <a:rPr lang="en-US"/>
               <a:t>Presentation title</a:t>
             </a:r>
-            <a:endParaRPr lang="en-US" dirty="0"/>
           </a:p>
         </p:txBody>
       </p:sp>
@@ -24662,7 +24569,7 @@
               <a:pPr/>
               <a:t>5/3/2026</a:t>
             </a:fld>
-            <a:endParaRPr lang="en-US" dirty="0"/>
+            <a:endParaRPr lang="en-US"/>
           </a:p>
         </p:txBody>
       </p:sp>
@@ -24710,7 +24617,7 @@
               <a:pPr/>
               <a:t>‹#›</a:t>
             </a:fld>
-            <a:endParaRPr lang="en-US" dirty="0"/>
+            <a:endParaRPr lang="en-US"/>
           </a:p>
         </p:txBody>
       </p:sp>
@@ -25254,7 +25161,7 @@
         <p:spPr>
           <a:xfrm>
             <a:off x="533401" y="1016955"/>
-            <a:ext cx="4573438" cy="1328932"/>
+            <a:ext cx="5281438" cy="1328932"/>
           </a:xfrm>
         </p:spPr>
         <p:txBody>
@@ -25264,8 +25171,11 @@
           <a:lstStyle/>
           <a:p>
             <a:r>
-              <a:rPr lang="en-GB" sz="3300"/>
-              <a:t>Market Overview + Trends</a:t>
+              <a:rPr lang="en-GB" sz="3300">
+                <a:latin typeface="Arial Black"/>
+                <a:cs typeface="Arial"/>
+              </a:rPr>
+              <a:t>Market Overview</a:t>
             </a:r>
           </a:p>
         </p:txBody>
@@ -25288,13 +25198,13 @@
         </p:nvSpPr>
         <p:spPr>
           <a:xfrm>
-            <a:off x="533401" y="2495232"/>
-            <a:ext cx="4242759" cy="3727767"/>
+            <a:off x="533401" y="1810724"/>
+            <a:ext cx="4242759" cy="4412275"/>
           </a:xfrm>
         </p:spPr>
         <p:txBody>
           <a:bodyPr vert="horz" lIns="91440" tIns="45720" rIns="91440" bIns="45720" rtlCol="0" anchor="t">
-            <a:normAutofit/>
+            <a:normAutofit lnSpcReduction="10000"/>
           </a:bodyPr>
           <a:lstStyle/>
           <a:p>
@@ -25304,10 +25214,10 @@
               </a:spcAft>
             </a:pPr>
             <a:r>
-              <a:rPr lang="en-GB" sz="1800">
+              <a:rPr lang="en-GB" sz="1800" dirty="0">
                 <a:cs typeface="Arial"/>
               </a:rPr>
-              <a:t>Market includes premium (Cuisinart, Oster) and mass brands (Ninja, Instant Pot)</a:t>
+              <a:t>Market is dominated by mass brands (Ninja, Instant Pot), with premium brands like Cuisinart and Oster occupying a smaller share due to high prices and low ratings</a:t>
             </a:r>
           </a:p>
           <a:p>
@@ -25333,7 +25243,13 @@
               <a:rPr lang="en-GB" sz="1800">
                 <a:cs typeface="Arial"/>
               </a:rPr>
-              <a:t>Instant Pot grew rapidly by lowering price and improving ratings</a:t>
+              <a:t>Explosive growth for Instant Pot by lowering prices and</a:t>
+            </a:r>
+            <a:r>
+              <a:rPr lang="en-GB" sz="1800" dirty="0">
+                <a:cs typeface="Arial"/>
+              </a:rPr>
+              <a:t> improving ratings</a:t>
             </a:r>
           </a:p>
           <a:p>
@@ -25343,11 +25259,33 @@
               </a:spcAft>
             </a:pPr>
             <a:r>
+              <a:rPr lang="en-GB" sz="1800" dirty="0">
+                <a:cs typeface="Arial"/>
+              </a:rPr>
+              <a:t>High ratings does not mean low prices, with highest-rated Ninja </a:t>
+            </a:r>
+            <a:r>
               <a:rPr lang="en-GB" sz="1800">
                 <a:cs typeface="Arial"/>
               </a:rPr>
-              <a:t>Ratings are consistently high -&gt; price does not equal quality necessarily</a:t>
-            </a:r>
+              <a:t>being above all other highly-rated brands in price</a:t>
+            </a:r>
+          </a:p>
+          <a:p>
+            <a:pPr>
+              <a:spcAft>
+                <a:spcPts val="600"/>
+              </a:spcAft>
+            </a:pPr>
+            <a:r>
+              <a:rPr lang="en-GB" sz="1800">
+                <a:cs typeface="Arial"/>
+              </a:rPr>
+              <a:t>Appeal depends on more than just price</a:t>
+            </a:r>
+            <a:endParaRPr lang="en-GB" sz="1800" dirty="0">
+              <a:cs typeface="Arial"/>
+            </a:endParaRPr>
           </a:p>
         </p:txBody>
       </p:sp>
@@ -25551,7 +25489,7 @@
               <a:buNone/>
             </a:pPr>
             <a:r>
-              <a:rPr lang="en-US" b="1" dirty="0">
+              <a:rPr lang="en-US" sz="1600" b="1" dirty="0">
                 <a:solidFill>
                   <a:srgbClr val="3B4546"/>
                 </a:solidFill>
@@ -25561,142 +25499,72 @@
               <a:t>log(</a:t>
             </a:r>
             <a:r>
-              <a:rPr lang="en-US" b="1" dirty="0" err="1">
+              <a:rPr lang="en-US" sz="1600" b="1" dirty="0" err="1">
                 <a:solidFill>
                   <a:srgbClr val="3B4546"/>
                 </a:solidFill>
                 <a:ea typeface="+mn-lt"/>
                 <a:cs typeface="+mn-lt"/>
               </a:rPr>
-              <a:t>s</a:t>
-            </a:r>
-            <a:r>
-              <a:rPr lang="en-US" sz="900" b="1" dirty="0" err="1">
+              <a:t>sbt</a:t>
+            </a:r>
+            <a:r>
+              <a:rPr lang="en-US" sz="1600" b="1" dirty="0">
                 <a:solidFill>
                   <a:srgbClr val="3B4546"/>
                 </a:solidFill>
                 <a:ea typeface="+mn-lt"/>
                 <a:cs typeface="+mn-lt"/>
               </a:rPr>
-              <a:t>bt</a:t>
-            </a:r>
-            <a:r>
-              <a:rPr lang="en-US" b="1" dirty="0">
+              <a:t>) = α + β(price </a:t>
+            </a:r>
+            <a:r>
+              <a:rPr lang="en-US" sz="1600" b="1" dirty="0" err="1">
                 <a:solidFill>
                   <a:srgbClr val="3B4546"/>
                 </a:solidFill>
                 <a:ea typeface="+mn-lt"/>
                 <a:cs typeface="+mn-lt"/>
               </a:rPr>
-              <a:t>) = α + β</a:t>
-            </a:r>
-            <a:r>
-              <a:rPr lang="en-US" sz="900" b="1" dirty="0">
+              <a:t>pbt</a:t>
+            </a:r>
+            <a:r>
+              <a:rPr lang="en-US" sz="1600" b="1" dirty="0">
                 <a:solidFill>
                   <a:srgbClr val="3B4546"/>
                 </a:solidFill>
                 <a:ea typeface="+mn-lt"/>
                 <a:cs typeface="+mn-lt"/>
               </a:rPr>
-              <a:t>price</a:t>
-            </a:r>
-            <a:r>
-              <a:rPr lang="en-US" b="1" dirty="0">
+              <a:t>) + β(rating </a:t>
+            </a:r>
+            <a:r>
+              <a:rPr lang="en-US" sz="1600" b="1" dirty="0" err="1">
                 <a:solidFill>
                   <a:srgbClr val="3B4546"/>
                 </a:solidFill>
                 <a:ea typeface="+mn-lt"/>
                 <a:cs typeface="+mn-lt"/>
               </a:rPr>
-              <a:t> </a:t>
-            </a:r>
-            <a:r>
-              <a:rPr lang="en-US" b="1" dirty="0" err="1">
+              <a:t>rbt</a:t>
+            </a:r>
+            <a:r>
+              <a:rPr lang="en-US" sz="1600" b="1" dirty="0">
                 <a:solidFill>
                   <a:srgbClr val="3B4546"/>
                 </a:solidFill>
                 <a:ea typeface="+mn-lt"/>
                 <a:cs typeface="+mn-lt"/>
               </a:rPr>
-              <a:t>p</a:t>
-            </a:r>
-            <a:r>
-              <a:rPr lang="en-US" sz="900" b="1" dirty="0" err="1">
-                <a:solidFill>
-                  <a:srgbClr val="3B4546"/>
-                </a:solidFill>
-                <a:ea typeface="+mn-lt"/>
-                <a:cs typeface="+mn-lt"/>
-              </a:rPr>
-              <a:t>bt</a:t>
-            </a:r>
-            <a:r>
-              <a:rPr lang="en-US" b="1" dirty="0">
-                <a:solidFill>
-                  <a:srgbClr val="3B4546"/>
-                </a:solidFill>
-                <a:ea typeface="+mn-lt"/>
-                <a:cs typeface="+mn-lt"/>
-              </a:rPr>
-              <a:t> + β</a:t>
-            </a:r>
-            <a:r>
-              <a:rPr lang="en-US" sz="900" b="1" dirty="0">
-                <a:solidFill>
-                  <a:srgbClr val="3B4546"/>
-                </a:solidFill>
-                <a:ea typeface="+mn-lt"/>
-                <a:cs typeface="+mn-lt"/>
-              </a:rPr>
-              <a:t>rating</a:t>
-            </a:r>
-            <a:r>
-              <a:rPr lang="en-US" b="1" dirty="0">
-                <a:solidFill>
-                  <a:srgbClr val="3B4546"/>
-                </a:solidFill>
-                <a:ea typeface="+mn-lt"/>
-                <a:cs typeface="+mn-lt"/>
-              </a:rPr>
-              <a:t> </a:t>
-            </a:r>
-            <a:r>
-              <a:rPr lang="en-US" b="1" dirty="0" err="1">
-                <a:solidFill>
-                  <a:srgbClr val="3B4546"/>
-                </a:solidFill>
-                <a:ea typeface="+mn-lt"/>
-                <a:cs typeface="+mn-lt"/>
-              </a:rPr>
-              <a:t>r</a:t>
-            </a:r>
-            <a:r>
-              <a:rPr lang="en-US" sz="900" b="1" dirty="0" err="1">
-                <a:solidFill>
-                  <a:srgbClr val="3B4546"/>
-                </a:solidFill>
-                <a:ea typeface="+mn-lt"/>
-                <a:cs typeface="+mn-lt"/>
-              </a:rPr>
-              <a:t>bt</a:t>
-            </a:r>
-            <a:r>
-              <a:rPr lang="en-US" b="1" dirty="0">
-                <a:solidFill>
-                  <a:srgbClr val="3B4546"/>
-                </a:solidFill>
-                <a:ea typeface="+mn-lt"/>
-                <a:cs typeface="+mn-lt"/>
-              </a:rPr>
-              <a:t> + features + brand effects + year</a:t>
-            </a:r>
-            <a:endParaRPr lang="en-US" b="1" dirty="0">
+              <a:t>) + features + brand dummies + year dummies</a:t>
+            </a:r>
+            <a:endParaRPr lang="en-US" sz="1600" b="1" dirty="0">
               <a:ea typeface="+mn-lt"/>
               <a:cs typeface="+mn-lt"/>
             </a:endParaRPr>
           </a:p>
           <a:p>
-            <a:endParaRPr lang="en-US" sz="1100" dirty="0">
+            <a:endParaRPr lang="en-US" sz="1100">
               <a:solidFill>
                 <a:srgbClr val="E4E4E4"/>
               </a:solidFill>
@@ -25724,7 +25592,7 @@
           <a:p>
             <a:pPr marL="285750" indent="-285750"/>
             <a:r>
-              <a:rPr lang="en-US" sz="1800">
+              <a:rPr lang="en-US" sz="1800" dirty="0">
                 <a:solidFill>
                   <a:srgbClr val="3B4546"/>
                 </a:solidFill>
@@ -25732,23 +25600,10 @@
                 <a:ea typeface="+mn-lt"/>
                 <a:cs typeface="Arial"/>
               </a:rPr>
-              <a:t>Brand and year effects control for:</a:t>
-            </a:r>
-            <a:endParaRPr lang="en-US" sz="1800">
-              <a:solidFill>
-                <a:srgbClr val="3B4546"/>
-              </a:solidFill>
-              <a:latin typeface="Arial"/>
-              <a:ea typeface="+mn-lt"/>
-            </a:endParaRPr>
-          </a:p>
-          <a:p>
-            <a:pPr marL="514350" lvl="1" indent="-285750">
-              <a:buFont typeface="Courier New" panose="020B0604020202020204" pitchFamily="34" charset="0"/>
-              <a:buChar char="o"/>
-            </a:pPr>
-            <a:r>
-              <a:rPr lang="en-US" sz="1800">
+              <a:t>Brand and year dummies are interpreted relative to the dropped reference categories (</a:t>
+            </a:r>
+            <a:r>
+              <a:rPr lang="en-US" sz="1800" dirty="0" err="1">
                 <a:solidFill>
                   <a:srgbClr val="3B4546"/>
                 </a:solidFill>
@@ -25756,16 +25611,10 @@
                 <a:ea typeface="+mn-lt"/>
                 <a:cs typeface="Arial"/>
               </a:rPr>
-              <a:t>Brand reputation</a:t>
-            </a:r>
-          </a:p>
-          <a:p>
-            <a:pPr marL="514350" lvl="1" indent="-285750">
-              <a:buFont typeface="Courier New" panose="020B0604020202020204" pitchFamily="34" charset="0"/>
-              <a:buChar char="o"/>
-            </a:pPr>
-            <a:r>
-              <a:rPr lang="en-US" sz="1800">
+              <a:t>Chefman</a:t>
+            </a:r>
+            <a:r>
+              <a:rPr lang="en-US" sz="1800" dirty="0">
                 <a:solidFill>
                   <a:srgbClr val="3B4546"/>
                 </a:solidFill>
@@ -25773,14 +25622,121 @@
                 <a:ea typeface="+mn-lt"/>
                 <a:cs typeface="Arial"/>
               </a:rPr>
-              <a:t>Market trends over time</a:t>
-            </a:r>
+              <a:t> and 2019, respectively)</a:t>
+            </a:r>
+            <a:endParaRPr lang="en-US" sz="1800" dirty="0">
+              <a:solidFill>
+                <a:srgbClr val="3B4546"/>
+              </a:solidFill>
+              <a:latin typeface="Arial"/>
+              <a:ea typeface="+mn-lt"/>
+            </a:endParaRPr>
+          </a:p>
+          <a:p>
+            <a:pPr marL="285750" indent="-285750"/>
+            <a:endParaRPr lang="en-US" sz="1800" dirty="0">
+              <a:solidFill>
+                <a:srgbClr val="3B4546"/>
+              </a:solidFill>
+              <a:latin typeface="Arial"/>
+              <a:ea typeface="+mn-lt"/>
+            </a:endParaRPr>
+          </a:p>
+          <a:p>
+            <a:pPr>
+              <a:lnSpc>
+                <a:spcPct val="150000"/>
+              </a:lnSpc>
+              <a:spcBef>
+                <a:spcPts val="0"/>
+              </a:spcBef>
+            </a:pPr>
+            <a:r>
+              <a:rPr lang="en-GB" sz="1800" b="1">
+                <a:solidFill>
+                  <a:srgbClr val="3B4546"/>
+                </a:solidFill>
+                <a:latin typeface="Arial"/>
+                <a:ea typeface="+mn-lt"/>
+                <a:cs typeface="Arial"/>
+              </a:rPr>
+              <a:t> Estimated price coefficient: </a:t>
+            </a:r>
+            <a:r>
+              <a:rPr lang="en-GB" sz="1800">
+                <a:solidFill>
+                  <a:srgbClr val="3B4546"/>
+                </a:solidFill>
+                <a:latin typeface="Arial"/>
+                <a:ea typeface="+mn-lt"/>
+                <a:cs typeface="Arial"/>
+              </a:rPr>
+              <a:t>β_price = -0.0377</a:t>
+            </a:r>
+            <a:endParaRPr lang="en-US" sz="1800">
+              <a:solidFill>
+                <a:srgbClr val="000000"/>
+              </a:solidFill>
+              <a:latin typeface="Arial"/>
+              <a:ea typeface="+mn-lt"/>
+            </a:endParaRPr>
+          </a:p>
+          <a:p>
+            <a:pPr marL="285750" indent="-285750">
+              <a:lnSpc>
+                <a:spcPct val="150000"/>
+              </a:lnSpc>
+              <a:spcBef>
+                <a:spcPts val="0"/>
+              </a:spcBef>
+            </a:pPr>
+            <a:r>
+              <a:rPr lang="en-GB" sz="1800">
+                <a:solidFill>
+                  <a:srgbClr val="3B4546"/>
+                </a:solidFill>
+                <a:latin typeface="Arial"/>
+                <a:ea typeface="+mn-lt"/>
+                <a:cs typeface="Arial"/>
+              </a:rPr>
+              <a:t>As expected, higher prices translate to lower demand</a:t>
+            </a:r>
+            <a:endParaRPr lang="en-US" sz="1800">
+              <a:solidFill>
+                <a:srgbClr val="000000"/>
+              </a:solidFill>
+              <a:latin typeface="Arial"/>
+              <a:ea typeface="+mn-lt"/>
+              <a:cs typeface="Arial"/>
+            </a:endParaRPr>
+          </a:p>
+          <a:p>
+            <a:pPr marL="285750" indent="-285750">
+              <a:lnSpc>
+                <a:spcPct val="150000"/>
+              </a:lnSpc>
+              <a:spcBef>
+                <a:spcPts val="0"/>
+              </a:spcBef>
+            </a:pPr>
+            <a:r>
+              <a:rPr lang="en-GB" sz="1800">
+                <a:solidFill>
+                  <a:srgbClr val="3B4546"/>
+                </a:solidFill>
+                <a:latin typeface="Arial"/>
+                <a:ea typeface="+mn-lt"/>
+                <a:cs typeface="Arial"/>
+              </a:rPr>
+              <a:t>Market share is price-sensitive</a:t>
+            </a:r>
+            <a:endParaRPr lang="en-US"/>
           </a:p>
           <a:p>
             <a:pPr marL="0" indent="0">
               <a:buNone/>
             </a:pPr>
-            <a:endParaRPr lang="en-US" dirty="0">
+            <a:endParaRPr lang="en-US">
               <a:solidFill>
                 <a:srgbClr val="3B4546"/>
               </a:solidFill>
@@ -25844,13 +25800,20 @@
           <a:lstStyle/>
           <a:p>
             <a:r>
+              <a:rPr lang="en-GB" sz="3600" dirty="0">
+                <a:latin typeface="Arial Black"/>
+                <a:cs typeface="Arial"/>
+              </a:rPr>
+              <a:t>Price and </a:t>
+            </a:r>
+            <a:r>
               <a:rPr lang="en-GB" sz="3600">
                 <a:latin typeface="Arial Black"/>
                 <a:cs typeface="Arial"/>
               </a:rPr>
-              <a:t>Price Effects + Features</a:t>
-            </a:r>
-            <a:endParaRPr lang="en-US" sz="3600"/>
+              <a:t>Features</a:t>
+            </a:r>
+            <a:endParaRPr lang="en-US" sz="3600" dirty="0" err="1"/>
           </a:p>
         </p:txBody>
       </p:sp>
@@ -25873,7 +25836,7 @@
         <p:spPr/>
         <p:txBody>
           <a:bodyPr vert="horz" lIns="91440" tIns="45720" rIns="91440" bIns="45720" rtlCol="0" anchor="t">
-            <a:normAutofit lnSpcReduction="10000"/>
+            <a:normAutofit fontScale="85000" lnSpcReduction="10000"/>
           </a:bodyPr>
           <a:lstStyle/>
           <a:p>
@@ -25881,62 +25844,20 @@
               <a:buNone/>
             </a:pPr>
             <a:r>
-              <a:rPr lang="en-GB" sz="1800" b="1">
-                <a:cs typeface="Arial"/>
-              </a:rPr>
-              <a:t>Estimated price coefficient:</a:t>
-            </a:r>
-            <a:endParaRPr lang="en-US" sz="1800" b="1"/>
-          </a:p>
-          <a:p>
-            <a:pPr marL="0" indent="0" algn="ctr">
-              <a:buNone/>
-            </a:pPr>
-            <a:r>
-              <a:rPr lang="en-GB" sz="1800">
-                <a:ea typeface="+mn-lt"/>
-                <a:cs typeface="+mn-lt"/>
-              </a:rPr>
-              <a:t>β_price </a:t>
-            </a:r>
-            <a:r>
-              <a:rPr lang="en-GB" sz="1800">
-                <a:solidFill>
-                  <a:srgbClr val="3B4546"/>
-                </a:solidFill>
-                <a:latin typeface="Arial"/>
-                <a:ea typeface="Roboto"/>
-                <a:cs typeface="Arial"/>
-              </a:rPr>
-              <a:t>= </a:t>
-            </a:r>
-            <a:r>
-              <a:rPr lang="en-GB" sz="1800">
-                <a:ea typeface="+mn-lt"/>
-                <a:cs typeface="+mn-lt"/>
-              </a:rPr>
-              <a:t>-0.0377</a:t>
-            </a:r>
-          </a:p>
-          <a:p>
-            <a:pPr marL="0" indent="0">
-              <a:buNone/>
-            </a:pPr>
-            <a:r>
-              <a:rPr lang="en-GB" sz="1800" b="1">
+              <a:rPr lang="en-GB" sz="1800" dirty="0">
                 <a:cs typeface="Arial" panose="020B0604020202020204"/>
               </a:rPr>
-              <a:t>Interpretation:</a:t>
-            </a:r>
-          </a:p>
-          <a:p>
-            <a:pPr marL="285750" indent="-285750"/>
+              <a:t>Top demand drivers (brands with these features tend to have greater market </a:t>
+            </a:r>
             <a:r>
               <a:rPr lang="en-GB" sz="1800">
                 <a:cs typeface="Arial" panose="020B0604020202020204"/>
               </a:rPr>
-              <a:t>Higher prices       Lower Demand (expected)</a:t>
-            </a:r>
+              <a:t>share):</a:t>
+            </a:r>
+            <a:endParaRPr lang="en-GB" sz="1800" dirty="0">
+              <a:cs typeface="Arial" panose="020B0604020202020204"/>
+            </a:endParaRPr>
           </a:p>
           <a:p>
             <a:pPr marL="285750" indent="-285750"/>
@@ -25944,7 +25865,26 @@
               <a:rPr lang="en-GB" sz="1800">
                 <a:cs typeface="Arial" panose="020B0604020202020204"/>
               </a:rPr>
-              <a:t>Market is price-sensitive</a:t>
+              <a:t>Viewing windows</a:t>
+            </a:r>
+          </a:p>
+          <a:p>
+            <a:pPr marL="285750" indent="-285750"/>
+            <a:r>
+              <a:rPr lang="en-GB" sz="1800">
+                <a:cs typeface="Arial" panose="020B0604020202020204"/>
+              </a:rPr>
+              <a:t>Compact designs</a:t>
+            </a:r>
+            <a:endParaRPr lang="en-GB"/>
+          </a:p>
+          <a:p>
+            <a:pPr marL="285750" indent="-285750"/>
+            <a:r>
+              <a:rPr lang="en-GB" sz="1800">
+                <a:cs typeface="Arial" panose="020B0604020202020204"/>
+              </a:rPr>
+              <a:t>Oven-style models</a:t>
             </a:r>
           </a:p>
           <a:p>
@@ -25960,86 +25900,36 @@
               <a:buNone/>
             </a:pPr>
             <a:r>
-              <a:rPr lang="en-GB" sz="1800" b="1">
+              <a:rPr lang="en-GB" sz="1800" dirty="0">
                 <a:cs typeface="Arial" panose="020B0604020202020204"/>
               </a:rPr>
-              <a:t>Top Demand Drivers:</a:t>
-            </a:r>
-          </a:p>
-          <a:p>
-            <a:pPr marL="285750" indent="-285750"/>
+              <a:t>Compact and oven-style are both the most common features across brands and the top demand drivers, indicating that consumers commonly expect these features in an air fryer.</a:t>
+            </a:r>
+          </a:p>
+          <a:p>
+            <a:pPr marL="0" indent="0">
+              <a:buNone/>
+            </a:pPr>
+            <a:endParaRPr lang="en-GB" sz="1800" dirty="0">
+              <a:cs typeface="Arial" panose="020B0604020202020204"/>
+            </a:endParaRPr>
+          </a:p>
+          <a:p>
+            <a:pPr marL="0" indent="0">
+              <a:buNone/>
+            </a:pPr>
+            <a:r>
+              <a:rPr lang="en-GB" sz="1800" dirty="0">
+                <a:cs typeface="Arial" panose="020B0604020202020204"/>
+              </a:rPr>
+              <a:t>On the flipside, brands with dual-basket designs and rotisserie-capable models tend to have </a:t>
+            </a:r>
             <a:r>
               <a:rPr lang="en-GB" sz="1800">
                 <a:cs typeface="Arial" panose="020B0604020202020204"/>
               </a:rPr>
-              <a:t>Compact designs</a:t>
-            </a:r>
-          </a:p>
-          <a:p>
-            <a:pPr marL="285750" indent="-285750"/>
-            <a:r>
-              <a:rPr lang="en-GB" sz="1800">
-                <a:cs typeface="Arial" panose="020B0604020202020204"/>
-              </a:rPr>
-              <a:t>Oven-style models</a:t>
-            </a:r>
-          </a:p>
-          <a:p>
-            <a:pPr marL="285750" indent="-285750"/>
-            <a:r>
-              <a:rPr lang="en-GB" sz="1800">
-                <a:cs typeface="Arial" panose="020B0604020202020204"/>
-              </a:rPr>
-              <a:t>Viewing windows</a:t>
-            </a:r>
-            <a:endParaRPr lang="en-GB" sz="1800" dirty="0">
-              <a:cs typeface="Arial" panose="020B0604020202020204"/>
-            </a:endParaRPr>
-          </a:p>
-        </p:txBody>
-      </p:sp>
-      <p:sp>
-        <p:nvSpPr>
-          <p:cNvPr id="4" name="Arrow: Right 3">
-            <a:extLst>
-              <a:ext uri="{FF2B5EF4-FFF2-40B4-BE49-F238E27FC236}">
-                <a16:creationId xmlns:a16="http://schemas.microsoft.com/office/drawing/2014/main" id="{84CDF2E2-792F-5FE0-9FE8-62EC01244136}"/>
-              </a:ext>
-            </a:extLst>
-          </p:cNvPr>
-          <p:cNvSpPr/>
-          <p:nvPr/>
-        </p:nvSpPr>
-        <p:spPr>
-          <a:xfrm>
-            <a:off x="2380710" y="3883547"/>
-            <a:ext cx="237368" cy="107894"/>
-          </a:xfrm>
-          <a:prstGeom prst="rightArrow">
-            <a:avLst/>
-          </a:prstGeom>
-        </p:spPr>
-        <p:style>
-          <a:lnRef idx="2">
-            <a:schemeClr val="accent1">
-              <a:shade val="15000"/>
-            </a:schemeClr>
-          </a:lnRef>
-          <a:fillRef idx="1">
-            <a:schemeClr val="accent1"/>
-          </a:fillRef>
-          <a:effectRef idx="0">
-            <a:schemeClr val="accent1"/>
-          </a:effectRef>
-          <a:fontRef idx="minor">
-            <a:schemeClr val="lt1"/>
-          </a:fontRef>
-        </p:style>
-        <p:txBody>
-          <a:bodyPr rtlCol="0" anchor="ctr"/>
-          <a:lstStyle/>
-          <a:p>
-            <a:pPr algn="ctr"/>
+              <a:t>smaller market share.</a:t>
+            </a:r>
             <a:endParaRPr lang="en-GB"/>
           </a:p>
         </p:txBody>
@@ -26129,8 +26019,8 @@
         </p:nvSpPr>
         <p:spPr>
           <a:xfrm>
-            <a:off x="4019552" y="1001715"/>
-            <a:ext cx="8171010" cy="2232334"/>
+            <a:off x="4019552" y="846732"/>
+            <a:ext cx="8171010" cy="2387317"/>
           </a:xfrm>
         </p:spPr>
         <p:txBody>
@@ -26139,6 +26029,14 @@
           </a:bodyPr>
           <a:lstStyle/>
           <a:p>
+            <a:r>
+              <a:rPr lang="en-US" sz="1800">
+                <a:cs typeface="Arial"/>
+              </a:rPr>
+              <a:t>Using our demand model, we estimated unit costs, markups, and share-weighted profits:</a:t>
+            </a:r>
+          </a:p>
+          <a:p>
             <a:pPr marL="285750" indent="-285750">
               <a:buChar char="•"/>
             </a:pPr>
@@ -26148,6 +26046,7 @@
               </a:rPr>
               <a:t>Premium brands show higher markups but lower market share</a:t>
             </a:r>
+            <a:endParaRPr lang="en-US" sz="1800"/>
           </a:p>
           <a:p>
             <a:pPr marL="285750" indent="-285750">
@@ -26158,17 +26057,6 @@
                 <a:cs typeface="Arial"/>
               </a:rPr>
               <a:t>Mass-market brands (e.g., Ninja) achieve higher share-weighted profits</a:t>
-            </a:r>
-          </a:p>
-          <a:p>
-            <a:pPr marL="285750" indent="-285750">
-              <a:buChar char="•"/>
-            </a:pPr>
-            <a:r>
-              <a:rPr lang="en-US" sz="1800">
-                <a:cs typeface="Arial"/>
-              </a:rPr>
-              <a:t>Profit is measured as share-weighted profit derived from the demand model</a:t>
             </a:r>
           </a:p>
           <a:p>
@@ -26311,11 +26199,8 @@
               <a:rPr lang="en-GB" sz="1800">
                 <a:cs typeface="Arial"/>
               </a:rPr>
-              <a:t>Market is competitive + price-sensitive</a:t>
-            </a:r>
-            <a:endParaRPr lang="en-GB" sz="1800" dirty="0">
-              <a:cs typeface="Arial"/>
-            </a:endParaRPr>
+              <a:t>Air fryer market is competitive and price-sensitive</a:t>
+            </a:r>
           </a:p>
           <a:p>
             <a:r>
@@ -26326,23 +26211,18 @@
             </a:r>
           </a:p>
           <a:p>
-            <a:pPr marL="0" indent="0">
-              <a:buNone/>
-            </a:pPr>
-            <a:endParaRPr lang="en-GB" sz="1800" dirty="0">
-              <a:cs typeface="Arial"/>
-            </a:endParaRPr>
-          </a:p>
-          <a:p>
+            <a:r>
+              <a:rPr lang="en-GB" sz="1800" dirty="0">
+                <a:cs typeface="Arial"/>
+              </a:rPr>
+              <a:t>Based on our </a:t>
+            </a:r>
             <a:r>
               <a:rPr lang="en-GB" sz="1800">
                 <a:cs typeface="Arial"/>
               </a:rPr>
-              <a:t>Winning strategy:</a:t>
-            </a:r>
-            <a:endParaRPr lang="en-GB" sz="1800" dirty="0">
-              <a:cs typeface="Arial"/>
-            </a:endParaRPr>
+              <a:t>model, a brand's winning strategy includes:</a:t>
+            </a:r>
           </a:p>
           <a:p>
             <a:pPr lvl="1">
@@ -26355,7 +26235,7 @@
               </a:rPr>
               <a:t>Competitive pricing</a:t>
             </a:r>
-            <a:endParaRPr lang="en-GB" sz="1800" dirty="0"/>
+            <a:endParaRPr lang="en-GB" sz="1800"/>
           </a:p>
           <a:p>
             <a:pPr lvl="1">
@@ -26368,7 +26248,7 @@
               </a:rPr>
               <a:t>Strong consumer ratings</a:t>
             </a:r>
-            <a:endParaRPr lang="en-GB" sz="1800" dirty="0"/>
+            <a:endParaRPr lang="en-GB" sz="1800"/>
           </a:p>
           <a:p>
             <a:pPr lvl="1">
@@ -26379,15 +26259,15 @@
               <a:rPr lang="en-GB" sz="1800">
                 <a:cs typeface="Arial"/>
               </a:rPr>
-              <a:t>Practical, high-value features</a:t>
-            </a:r>
-            <a:endParaRPr lang="en-GB" sz="1800" dirty="0"/>
+              <a:t>Practical, in-demand, high-value features</a:t>
+            </a:r>
+            <a:endParaRPr lang="en-GB" sz="1800"/>
           </a:p>
           <a:p>
             <a:pPr marL="228600" lvl="1" indent="0">
               <a:buNone/>
             </a:pPr>
-            <a:endParaRPr lang="en-GB" sz="1800" dirty="0">
+            <a:endParaRPr lang="en-GB" sz="1800">
               <a:cs typeface="Arial"/>
             </a:endParaRPr>
           </a:p>
@@ -26397,22 +26277,44 @@
               <a:rPr lang="en-GB" sz="1800">
                 <a:cs typeface="Arial"/>
               </a:rPr>
-              <a:t>Ninja = Strongest Overall Position</a:t>
+              <a:t>Ninja occupies the strongest overall position</a:t>
+            </a:r>
+            <a:endParaRPr lang="en-GB" sz="1800"/>
+          </a:p>
+          <a:p>
+            <a:pPr indent="-285750"/>
+            <a:r>
+              <a:rPr lang="en-GB" sz="1800" dirty="0">
+                <a:cs typeface="Arial"/>
+              </a:rPr>
+              <a:t>Instant Pot exhibits the fastest growth trajectory</a:t>
             </a:r>
             <a:endParaRPr lang="en-GB" sz="1800" dirty="0"/>
           </a:p>
           <a:p>
             <a:pPr indent="-285750"/>
+            <a:r>
+              <a:rPr lang="en-GB" sz="1800" dirty="0">
+                <a:cs typeface="Arial"/>
+              </a:rPr>
+              <a:t>Premium brands like Cuisinart and Oster face </a:t>
+            </a:r>
             <a:r>
               <a:rPr lang="en-GB" sz="1800">
                 <a:cs typeface="Arial"/>
               </a:rPr>
-              <a:t>Instant Pot = Fastest Growth Trajectory</a:t>
-            </a:r>
-            <a:endParaRPr lang="en-GB" sz="1800"/>
-          </a:p>
-          <a:p>
-            <a:endParaRPr lang="en-GB" dirty="0"/>
+              <a:t>declining market share in the face of price decreases, rating drops, and profit </a:t>
+            </a:r>
+            <a:r>
+              <a:rPr lang="en-GB" sz="1800" dirty="0">
+                <a:cs typeface="Arial"/>
+              </a:rPr>
+              <a:t>losses</a:t>
+            </a:r>
+            <a:endParaRPr lang="en-GB" sz="1800" dirty="0"/>
+          </a:p>
+          <a:p>
+            <a:endParaRPr lang="en-GB"/>
           </a:p>
         </p:txBody>
       </p:sp>
@@ -27321,35 +27223,6 @@
 </file>
 
 <file path=customXml/item1.xml><?xml version="1.0" encoding="utf-8"?>
-<?mso-contentType ?>
-<FormTemplates xmlns="http://schemas.microsoft.com/sharepoint/v3/contenttype/forms">
-  <Display>DocumentLibraryForm</Display>
-  <Edit>DocumentLibraryForm</Edit>
-  <New>DocumentLibraryForm</New>
-</FormTemplates>
-</file>
-
-<file path=customXml/item2.xml><?xml version="1.0" encoding="utf-8"?>
-<p:properties xmlns:p="http://schemas.microsoft.com/office/2006/metadata/properties" xmlns:xsi="http://www.w3.org/2001/XMLSchema-instance" xmlns:pc="http://schemas.microsoft.com/office/infopath/2007/PartnerControls">
-  <documentManagement>
-    <_ip_UnifiedCompliancePolicyUIAction xmlns="http://schemas.microsoft.com/sharepoint/v3" xsi:nil="true"/>
-    <Image xmlns="71af3243-3dd4-4a8d-8c0d-dd76da1f02a5">
-      <Url xsi:nil="true"/>
-      <Description xsi:nil="true"/>
-    </Image>
-    <Status xmlns="71af3243-3dd4-4a8d-8c0d-dd76da1f02a5">Not started</Status>
-    <Background xmlns="71af3243-3dd4-4a8d-8c0d-dd76da1f02a5">false</Background>
-    <_ip_UnifiedCompliancePolicyProperties xmlns="http://schemas.microsoft.com/sharepoint/v3" xsi:nil="true"/>
-    <ImageTagsTaxHTField xmlns="71af3243-3dd4-4a8d-8c0d-dd76da1f02a5">
-      <Terms xmlns="http://schemas.microsoft.com/office/infopath/2007/PartnerControls"/>
-    </ImageTagsTaxHTField>
-    <TaxCatchAll xmlns="230e9df3-be65-4c73-a93b-d1236ebd677e" xsi:nil="true"/>
-    <MediaServiceKeyPoints xmlns="71af3243-3dd4-4a8d-8c0d-dd76da1f02a5" xsi:nil="true"/>
-  </documentManagement>
-</p:properties>
-</file>
-
-<file path=customXml/item3.xml><?xml version="1.0" encoding="utf-8"?>
 <ct:contentTypeSchema xmlns:ct="http://schemas.microsoft.com/office/2006/metadata/contentType" xmlns:ma="http://schemas.microsoft.com/office/2006/metadata/properties/metaAttributes" ct:_="" ma:_="" ma:contentTypeName="Document" ma:contentTypeID="0x01010079F111ED35F8CC479449609E8A0923A6" ma:contentTypeVersion="30" ma:contentTypeDescription="Create a new document." ma:contentTypeScope="" ma:versionID="cec0622158e8f13124e9e8fd4de31bd1">
   <xsd:schema xmlns:xsd="http://www.w3.org/2001/XMLSchema" xmlns:xs="http://www.w3.org/2001/XMLSchema" xmlns:p="http://schemas.microsoft.com/office/2006/metadata/properties" xmlns:ns1="http://schemas.microsoft.com/sharepoint/v3" xmlns:ns2="71af3243-3dd4-4a8d-8c0d-dd76da1f02a5" xmlns:ns3="16c05727-aa75-4e4a-9b5f-8a80a1165891" xmlns:ns4="230e9df3-be65-4c73-a93b-d1236ebd677e" targetNamespace="http://schemas.microsoft.com/office/2006/metadata/properties" ma:root="true" ma:fieldsID="3b52f30ab005d15df08657af532e6e38" ns1:_="" ns2:_="" ns3:_="" ns4:_="">
     <xsd:import namespace="http://schemas.microsoft.com/sharepoint/v3"/>
@@ -27667,7 +27540,57 @@
 </ct:contentTypeSchema>
 </file>
 
+<file path=customXml/item2.xml><?xml version="1.0" encoding="utf-8"?>
+<?mso-contentType ?>
+<FormTemplates xmlns="http://schemas.microsoft.com/sharepoint/v3/contenttype/forms">
+  <Display>DocumentLibraryForm</Display>
+  <Edit>DocumentLibraryForm</Edit>
+  <New>DocumentLibraryForm</New>
+</FormTemplates>
+</file>
+
+<file path=customXml/item3.xml><?xml version="1.0" encoding="utf-8"?>
+<p:properties xmlns:p="http://schemas.microsoft.com/office/2006/metadata/properties" xmlns:xsi="http://www.w3.org/2001/XMLSchema-instance" xmlns:pc="http://schemas.microsoft.com/office/infopath/2007/PartnerControls">
+  <documentManagement>
+    <_ip_UnifiedCompliancePolicyUIAction xmlns="http://schemas.microsoft.com/sharepoint/v3" xsi:nil="true"/>
+    <Image xmlns="71af3243-3dd4-4a8d-8c0d-dd76da1f02a5">
+      <Url xsi:nil="true"/>
+      <Description xsi:nil="true"/>
+    </Image>
+    <Status xmlns="71af3243-3dd4-4a8d-8c0d-dd76da1f02a5">Not started</Status>
+    <Background xmlns="71af3243-3dd4-4a8d-8c0d-dd76da1f02a5">false</Background>
+    <_ip_UnifiedCompliancePolicyProperties xmlns="http://schemas.microsoft.com/sharepoint/v3" xsi:nil="true"/>
+    <ImageTagsTaxHTField xmlns="71af3243-3dd4-4a8d-8c0d-dd76da1f02a5">
+      <Terms xmlns="http://schemas.microsoft.com/office/infopath/2007/PartnerControls"/>
+    </ImageTagsTaxHTField>
+    <TaxCatchAll xmlns="230e9df3-be65-4c73-a93b-d1236ebd677e" xsi:nil="true"/>
+    <MediaServiceKeyPoints xmlns="71af3243-3dd4-4a8d-8c0d-dd76da1f02a5" xsi:nil="true"/>
+  </documentManagement>
+</p:properties>
+</file>
+
 <file path=customXml/itemProps1.xml><?xml version="1.0" encoding="utf-8"?>
+<ds:datastoreItem xmlns:ds="http://schemas.openxmlformats.org/officeDocument/2006/customXml" ds:itemID="{3766CE19-BB35-48A2-AFDA-766E83330032}">
+  <ds:schemaRefs>
+    <ds:schemaRef ds:uri="16c05727-aa75-4e4a-9b5f-8a80a1165891"/>
+    <ds:schemaRef ds:uri="230e9df3-be65-4c73-a93b-d1236ebd677e"/>
+    <ds:schemaRef ds:uri="71af3243-3dd4-4a8d-8c0d-dd76da1f02a5"/>
+    <ds:schemaRef ds:uri="http://purl.org/dc/elements/1.1/"/>
+    <ds:schemaRef ds:uri="http://purl.org/dc/terms/"/>
+    <ds:schemaRef ds:uri="http://schemas.microsoft.com/internal/obd"/>
+    <ds:schemaRef ds:uri="http://schemas.microsoft.com/office/2006/documentManagement/types"/>
+    <ds:schemaRef ds:uri="http://schemas.microsoft.com/office/2006/metadata/contentType"/>
+    <ds:schemaRef ds:uri="http://schemas.microsoft.com/office/2006/metadata/properties"/>
+    <ds:schemaRef ds:uri="http://schemas.microsoft.com/office/2006/metadata/properties/metaAttributes"/>
+    <ds:schemaRef ds:uri="http://schemas.microsoft.com/office/infopath/2007/PartnerControls"/>
+    <ds:schemaRef ds:uri="http://schemas.microsoft.com/sharepoint/v3"/>
+    <ds:schemaRef ds:uri="http://schemas.openxmlformats.org/package/2006/metadata/core-properties"/>
+    <ds:schemaRef ds:uri="http://www.w3.org/2001/XMLSchema"/>
+  </ds:schemaRefs>
+</ds:datastoreItem>
+</file>
+
+<file path=customXml/itemProps2.xml><?xml version="1.0" encoding="utf-8"?>
 <ds:datastoreItem xmlns:ds="http://schemas.openxmlformats.org/officeDocument/2006/customXml" ds:itemID="{38E339AF-67FC-4BA3-8B2E-038B3ED310D5}">
   <ds:schemaRefs>
     <ds:schemaRef ds:uri="http://schemas.microsoft.com/sharepoint/v3/contenttype/forms"/>
@@ -27675,42 +27598,21 @@
 </ds:datastoreItem>
 </file>
 
-<file path=customXml/itemProps2.xml><?xml version="1.0" encoding="utf-8"?>
+<file path=customXml/itemProps3.xml><?xml version="1.0" encoding="utf-8"?>
 <ds:datastoreItem xmlns:ds="http://schemas.openxmlformats.org/officeDocument/2006/customXml" ds:itemID="{4B99ED26-B189-4BA1-99D0-1112D8C2F106}">
   <ds:schemaRefs>
-    <ds:schemaRef ds:uri="http://purl.org/dc/dcmitype/"/>
-    <ds:schemaRef ds:uri="http://schemas.microsoft.com/office/2006/metadata/properties"/>
-    <ds:schemaRef ds:uri="http://schemas.microsoft.com/office/infopath/2007/PartnerControls"/>
-    <ds:schemaRef ds:uri="http://purl.org/dc/terms/"/>
-    <ds:schemaRef ds:uri="http://purl.org/dc/elements/1.1/"/>
-    <ds:schemaRef ds:uri="http://schemas.microsoft.com/office/2006/documentManagement/types"/>
-    <ds:schemaRef ds:uri="http://schemas.microsoft.com/sharepoint/v3"/>
-    <ds:schemaRef ds:uri="http://schemas.openxmlformats.org/package/2006/metadata/core-properties"/>
     <ds:schemaRef ds:uri="16c05727-aa75-4e4a-9b5f-8a80a1165891"/>
     <ds:schemaRef ds:uri="230e9df3-be65-4c73-a93b-d1236ebd677e"/>
     <ds:schemaRef ds:uri="71af3243-3dd4-4a8d-8c0d-dd76da1f02a5"/>
-    <ds:schemaRef ds:uri="http://www.w3.org/XML/1998/namespace"/>
-  </ds:schemaRefs>
-</ds:datastoreItem>
-</file>
-
-<file path=customXml/itemProps3.xml><?xml version="1.0" encoding="utf-8"?>
-<ds:datastoreItem xmlns:ds="http://schemas.openxmlformats.org/officeDocument/2006/customXml" ds:itemID="{3766CE19-BB35-48A2-AFDA-766E83330032}">
-  <ds:schemaRefs>
-    <ds:schemaRef ds:uri="http://schemas.microsoft.com/office/2006/metadata/contentType"/>
-    <ds:schemaRef ds:uri="http://schemas.microsoft.com/office/2006/metadata/properties/metaAttributes"/>
-    <ds:schemaRef ds:uri="http://www.w3.org/2001/XMLSchema"/>
-    <ds:schemaRef ds:uri="http://schemas.microsoft.com/office/2006/metadata/properties"/>
-    <ds:schemaRef ds:uri="http://schemas.microsoft.com/sharepoint/v3"/>
-    <ds:schemaRef ds:uri="71af3243-3dd4-4a8d-8c0d-dd76da1f02a5"/>
-    <ds:schemaRef ds:uri="16c05727-aa75-4e4a-9b5f-8a80a1165891"/>
-    <ds:schemaRef ds:uri="230e9df3-be65-4c73-a93b-d1236ebd677e"/>
-    <ds:schemaRef ds:uri="http://schemas.microsoft.com/office/2006/documentManagement/types"/>
-    <ds:schemaRef ds:uri="http://schemas.microsoft.com/office/infopath/2007/PartnerControls"/>
-    <ds:schemaRef ds:uri="http://schemas.openxmlformats.org/package/2006/metadata/core-properties"/>
+    <ds:schemaRef ds:uri="http://purl.org/dc/dcmitype/"/>
     <ds:schemaRef ds:uri="http://purl.org/dc/elements/1.1/"/>
     <ds:schemaRef ds:uri="http://purl.org/dc/terms/"/>
-    <ds:schemaRef ds:uri="http://schemas.microsoft.com/internal/obd"/>
+    <ds:schemaRef ds:uri="http://schemas.microsoft.com/office/2006/documentManagement/types"/>
+    <ds:schemaRef ds:uri="http://schemas.microsoft.com/office/2006/metadata/properties"/>
+    <ds:schemaRef ds:uri="http://schemas.microsoft.com/office/infopath/2007/PartnerControls"/>
+    <ds:schemaRef ds:uri="http://schemas.microsoft.com/sharepoint/v3"/>
+    <ds:schemaRef ds:uri="http://schemas.openxmlformats.org/package/2006/metadata/core-properties"/>
+    <ds:schemaRef ds:uri="http://www.w3.org/XML/1998/namespace"/>
   </ds:schemaRefs>
 </ds:datastoreItem>
 </file>

</xml_diff>